<commit_message>
Architecture slide: native shapes instead of embedded PNG
Users saw a flat picture with selection handles. Revert to
centered editable PowerPoint boxes, arrows, and foundation bar.

Co-authored-by: vishnushankar9024 <vishnushankar9024@users.noreply.github.com>
</commit_message>
<xml_diff>
--- a/output/DAMAC_PMWeb_AI_Governance_Intelligence_Layer.pptx
+++ b/output/DAMAC_PMWeb_AI_Governance_Intelligence_Layer.pptx
@@ -8432,8 +8432,8 @@
         </p:nvSpPr>
         <p:spPr>
           <a:xfrm>
-            <a:off x="1536192" y="2258568"/>
-            <a:ext cx="3145536" cy="292608"/>
+            <a:off x="1572768" y="2258568"/>
+            <a:ext cx="3072384" cy="256032"/>
           </a:xfrm>
           <a:prstGeom prst="rect">
             <a:avLst/>
@@ -8555,8 +8555,8 @@
         </p:nvSpPr>
         <p:spPr>
           <a:xfrm>
-            <a:off x="1536192" y="3063240"/>
-            <a:ext cx="3145536" cy="292608"/>
+            <a:off x="1572768" y="3063240"/>
+            <a:ext cx="3072384" cy="256032"/>
           </a:xfrm>
           <a:prstGeom prst="rect">
             <a:avLst/>
@@ -8678,8 +8678,8 @@
         </p:nvSpPr>
         <p:spPr>
           <a:xfrm>
-            <a:off x="1536192" y="3867912"/>
-            <a:ext cx="3145536" cy="292608"/>
+            <a:off x="1572768" y="3867912"/>
+            <a:ext cx="3072384" cy="256032"/>
           </a:xfrm>
           <a:prstGeom prst="rect">
             <a:avLst/>
@@ -8924,8 +8924,8 @@
         </p:nvSpPr>
         <p:spPr>
           <a:xfrm>
-            <a:off x="6931152" y="2167128"/>
-            <a:ext cx="4151376" cy="292608"/>
+            <a:off x="6967728" y="2167128"/>
+            <a:ext cx="4078224" cy="256032"/>
           </a:xfrm>
           <a:prstGeom prst="rect">
             <a:avLst/>
@@ -9008,8 +9008,8 @@
         </p:nvSpPr>
         <p:spPr>
           <a:xfrm>
-            <a:off x="6931152" y="2734056"/>
-            <a:ext cx="4151376" cy="292608"/>
+            <a:off x="6967728" y="2734056"/>
+            <a:ext cx="4078224" cy="256032"/>
           </a:xfrm>
           <a:prstGeom prst="rect">
             <a:avLst/>
@@ -9092,8 +9092,8 @@
         </p:nvSpPr>
         <p:spPr>
           <a:xfrm>
-            <a:off x="6931152" y="3300984"/>
-            <a:ext cx="4151376" cy="292608"/>
+            <a:off x="6967728" y="3300984"/>
+            <a:ext cx="4078224" cy="256032"/>
           </a:xfrm>
           <a:prstGeom prst="rect">
             <a:avLst/>
@@ -9176,8 +9176,8 @@
         </p:nvSpPr>
         <p:spPr>
           <a:xfrm>
-            <a:off x="6931152" y="3867912"/>
-            <a:ext cx="4151376" cy="292608"/>
+            <a:off x="6967728" y="3867912"/>
+            <a:ext cx="4078224" cy="256032"/>
           </a:xfrm>
           <a:prstGeom prst="rect">
             <a:avLst/>
@@ -9254,14 +9254,57 @@
       </p:sp>
       <p:sp>
         <p:nvSpPr>
-          <p:cNvPr id="34" name="TextBox 33"/>
-          <p:cNvSpPr txBox="1"/>
-          <p:nvPr/>
-        </p:nvSpPr>
-        <p:spPr>
-          <a:xfrm>
-            <a:off x="6931152" y="4434840"/>
-            <a:ext cx="4151376" cy="292608"/>
+          <p:cNvPr id="34" name="Rectangle 33"/>
+          <p:cNvSpPr/>
+          <p:nvPr/>
+        </p:nvSpPr>
+        <p:spPr>
+          <a:xfrm>
+            <a:off x="6858000" y="4343400"/>
+            <a:ext cx="64008" cy="475488"/>
+          </a:xfrm>
+          <a:prstGeom prst="rect">
+            <a:avLst/>
+          </a:prstGeom>
+          <a:solidFill>
+            <a:srgbClr val="E31837"/>
+          </a:solidFill>
+          <a:ln>
+            <a:noFill/>
+          </a:ln>
+        </p:spPr>
+        <p:style>
+          <a:lnRef idx="1">
+            <a:schemeClr val="accent1"/>
+          </a:lnRef>
+          <a:fillRef idx="3">
+            <a:schemeClr val="accent1"/>
+          </a:fillRef>
+          <a:effectRef idx="2">
+            <a:schemeClr val="accent1"/>
+          </a:effectRef>
+          <a:fontRef idx="minor">
+            <a:schemeClr val="lt1"/>
+          </a:fontRef>
+        </p:style>
+        <p:txBody>
+          <a:bodyPr rtlCol="0" anchor="ctr"/>
+          <a:lstStyle/>
+          <a:p>
+            <a:pPr algn="ctr"/>
+          </a:p>
+        </p:txBody>
+      </p:sp>
+      <p:sp>
+        <p:nvSpPr>
+          <p:cNvPr id="35" name="TextBox 34"/>
+          <p:cNvSpPr txBox="1"/>
+          <p:nvPr/>
+        </p:nvSpPr>
+        <p:spPr>
+          <a:xfrm>
+            <a:off x="6967728" y="4434840"/>
+            <a:ext cx="4078224" cy="256032"/>
           </a:xfrm>
           <a:prstGeom prst="rect">
             <a:avLst/>
@@ -10039,30 +10082,1066 @@
           </a:p>
         </p:txBody>
       </p:sp>
-      <p:pic>
-        <p:nvPicPr>
-          <p:cNvPr id="11" name="Picture 10" descr="architecture_stack.png"/>
-          <p:cNvPicPr>
-            <a:picLocks noChangeAspect="1"/>
-          </p:cNvPicPr>
-          <p:nvPr/>
-        </p:nvPicPr>
-        <p:blipFill>
-          <a:blip r:embed="rId3"/>
-          <a:stretch>
-            <a:fillRect/>
-          </a:stretch>
-        </p:blipFill>
-        <p:spPr>
-          <a:xfrm>
-            <a:off x="548640" y="1572768"/>
-            <a:ext cx="6163733" cy="4160520"/>
-          </a:xfrm>
-          <a:prstGeom prst="rect">
-            <a:avLst/>
-          </a:prstGeom>
-        </p:spPr>
-      </p:pic>
+      <p:sp>
+        <p:nvSpPr>
+          <p:cNvPr id="11" name="Rounded Rectangle 10"/>
+          <p:cNvSpPr/>
+          <p:nvPr/>
+        </p:nvSpPr>
+        <p:spPr>
+          <a:xfrm>
+            <a:off x="1523847" y="1627632"/>
+            <a:ext cx="9144000" cy="530352"/>
+          </a:xfrm>
+          <a:prstGeom prst="roundRect">
+            <a:avLst/>
+          </a:prstGeom>
+          <a:solidFill>
+            <a:srgbClr val="FFFFFF"/>
+          </a:solidFill>
+          <a:ln w="9525">
+            <a:solidFill>
+              <a:srgbClr val="DDDDDD"/>
+            </a:solidFill>
+          </a:ln>
+        </p:spPr>
+        <p:style>
+          <a:lnRef idx="1">
+            <a:schemeClr val="accent1"/>
+          </a:lnRef>
+          <a:fillRef idx="3">
+            <a:schemeClr val="accent1"/>
+          </a:fillRef>
+          <a:effectRef idx="2">
+            <a:schemeClr val="accent1"/>
+          </a:effectRef>
+          <a:fontRef idx="minor">
+            <a:schemeClr val="lt1"/>
+          </a:fontRef>
+        </p:style>
+        <p:txBody>
+          <a:bodyPr rtlCol="0" anchor="ctr"/>
+          <a:lstStyle/>
+          <a:p>
+            <a:pPr algn="ctr"/>
+          </a:p>
+        </p:txBody>
+      </p:sp>
+      <p:sp>
+        <p:nvSpPr>
+          <p:cNvPr id="12" name="TextBox 11"/>
+          <p:cNvSpPr txBox="1"/>
+          <p:nvPr/>
+        </p:nvSpPr>
+        <p:spPr>
+          <a:xfrm>
+            <a:off x="1633575" y="1719072"/>
+            <a:ext cx="8924544" cy="256032"/>
+          </a:xfrm>
+          <a:prstGeom prst="rect">
+            <a:avLst/>
+          </a:prstGeom>
+          <a:noFill/>
+        </p:spPr>
+        <p:txBody>
+          <a:bodyPr wrap="square">
+            <a:spAutoFit/>
+          </a:bodyPr>
+          <a:lstStyle/>
+          <a:p>
+            <a:pPr algn="ctr">
+              <a:lnSpc>
+                <a:spcPct val="115000"/>
+              </a:lnSpc>
+              <a:defRPr sz="1100" b="1">
+                <a:solidFill>
+                  <a:srgbClr val="1A1A1A"/>
+                </a:solidFill>
+                <a:latin typeface="Calibri"/>
+              </a:defRPr>
+            </a:pPr>
+            <a:r>
+              <a:t>Management Experience Layer</a:t>
+            </a:r>
+          </a:p>
+        </p:txBody>
+      </p:sp>
+      <p:sp>
+        <p:nvSpPr>
+          <p:cNvPr id="13" name="TextBox 12"/>
+          <p:cNvSpPr txBox="1"/>
+          <p:nvPr/>
+        </p:nvSpPr>
+        <p:spPr>
+          <a:xfrm>
+            <a:off x="1633575" y="1975104"/>
+            <a:ext cx="8924544" cy="128016"/>
+          </a:xfrm>
+          <a:prstGeom prst="rect">
+            <a:avLst/>
+          </a:prstGeom>
+          <a:noFill/>
+        </p:spPr>
+        <p:txBody>
+          <a:bodyPr wrap="square">
+            <a:spAutoFit/>
+          </a:bodyPr>
+          <a:lstStyle/>
+          <a:p>
+            <a:pPr algn="ctr">
+              <a:lnSpc>
+                <a:spcPct val="115000"/>
+              </a:lnSpc>
+              <a:defRPr sz="1100" b="0">
+                <a:solidFill>
+                  <a:srgbClr val="6B6B6B"/>
+                </a:solidFill>
+                <a:latin typeface="Calibri"/>
+              </a:defRPr>
+            </a:pPr>
+            <a:r>
+              <a:t>Dashboards · Chatbot · Approvals · Citations</a:t>
+            </a:r>
+          </a:p>
+        </p:txBody>
+      </p:sp>
+      <p:sp>
+        <p:nvSpPr>
+          <p:cNvPr id="14" name="TextBox 13"/>
+          <p:cNvSpPr txBox="1"/>
+          <p:nvPr/>
+        </p:nvSpPr>
+        <p:spPr>
+          <a:xfrm>
+            <a:off x="5967831" y="2167128"/>
+            <a:ext cx="256032" cy="128016"/>
+          </a:xfrm>
+          <a:prstGeom prst="rect">
+            <a:avLst/>
+          </a:prstGeom>
+          <a:noFill/>
+        </p:spPr>
+        <p:txBody>
+          <a:bodyPr wrap="square">
+            <a:spAutoFit/>
+          </a:bodyPr>
+          <a:lstStyle/>
+          <a:p>
+            <a:pPr algn="ctr">
+              <a:lnSpc>
+                <a:spcPct val="115000"/>
+              </a:lnSpc>
+              <a:defRPr sz="1100" b="1">
+                <a:solidFill>
+                  <a:srgbClr val="E31837"/>
+                </a:solidFill>
+                <a:latin typeface="Calibri"/>
+              </a:defRPr>
+            </a:pPr>
+            <a:r>
+              <a:t>▼</a:t>
+            </a:r>
+          </a:p>
+        </p:txBody>
+      </p:sp>
+      <p:sp>
+        <p:nvSpPr>
+          <p:cNvPr id="15" name="Rounded Rectangle 14"/>
+          <p:cNvSpPr/>
+          <p:nvPr/>
+        </p:nvSpPr>
+        <p:spPr>
+          <a:xfrm>
+            <a:off x="1523847" y="2286000"/>
+            <a:ext cx="9144000" cy="530352"/>
+          </a:xfrm>
+          <a:prstGeom prst="roundRect">
+            <a:avLst/>
+          </a:prstGeom>
+          <a:solidFill>
+            <a:srgbClr val="FDF2F4"/>
+          </a:solidFill>
+          <a:ln w="9525">
+            <a:solidFill>
+              <a:srgbClr val="E31837"/>
+            </a:solidFill>
+          </a:ln>
+        </p:spPr>
+        <p:style>
+          <a:lnRef idx="1">
+            <a:schemeClr val="accent1"/>
+          </a:lnRef>
+          <a:fillRef idx="3">
+            <a:schemeClr val="accent1"/>
+          </a:fillRef>
+          <a:effectRef idx="2">
+            <a:schemeClr val="accent1"/>
+          </a:effectRef>
+          <a:fontRef idx="minor">
+            <a:schemeClr val="lt1"/>
+          </a:fontRef>
+        </p:style>
+        <p:txBody>
+          <a:bodyPr rtlCol="0" anchor="ctr"/>
+          <a:lstStyle/>
+          <a:p>
+            <a:pPr algn="ctr"/>
+          </a:p>
+        </p:txBody>
+      </p:sp>
+      <p:sp>
+        <p:nvSpPr>
+          <p:cNvPr id="16" name="Rectangle 15"/>
+          <p:cNvSpPr/>
+          <p:nvPr/>
+        </p:nvSpPr>
+        <p:spPr>
+          <a:xfrm>
+            <a:off x="1523847" y="2286000"/>
+            <a:ext cx="64008" cy="530352"/>
+          </a:xfrm>
+          <a:prstGeom prst="rect">
+            <a:avLst/>
+          </a:prstGeom>
+          <a:solidFill>
+            <a:srgbClr val="E31837"/>
+          </a:solidFill>
+          <a:ln>
+            <a:noFill/>
+          </a:ln>
+        </p:spPr>
+        <p:style>
+          <a:lnRef idx="1">
+            <a:schemeClr val="accent1"/>
+          </a:lnRef>
+          <a:fillRef idx="3">
+            <a:schemeClr val="accent1"/>
+          </a:fillRef>
+          <a:effectRef idx="2">
+            <a:schemeClr val="accent1"/>
+          </a:effectRef>
+          <a:fontRef idx="minor">
+            <a:schemeClr val="lt1"/>
+          </a:fontRef>
+        </p:style>
+        <p:txBody>
+          <a:bodyPr rtlCol="0" anchor="ctr"/>
+          <a:lstStyle/>
+          <a:p>
+            <a:pPr algn="ctr"/>
+          </a:p>
+        </p:txBody>
+      </p:sp>
+      <p:sp>
+        <p:nvSpPr>
+          <p:cNvPr id="17" name="TextBox 16"/>
+          <p:cNvSpPr txBox="1"/>
+          <p:nvPr/>
+        </p:nvSpPr>
+        <p:spPr>
+          <a:xfrm>
+            <a:off x="1633575" y="2377440"/>
+            <a:ext cx="8924544" cy="256032"/>
+          </a:xfrm>
+          <a:prstGeom prst="rect">
+            <a:avLst/>
+          </a:prstGeom>
+          <a:noFill/>
+        </p:spPr>
+        <p:txBody>
+          <a:bodyPr wrap="square">
+            <a:spAutoFit/>
+          </a:bodyPr>
+          <a:lstStyle/>
+          <a:p>
+            <a:pPr algn="ctr">
+              <a:lnSpc>
+                <a:spcPct val="115000"/>
+              </a:lnSpc>
+              <a:defRPr sz="1100" b="1">
+                <a:solidFill>
+                  <a:srgbClr val="B01228"/>
+                </a:solidFill>
+                <a:latin typeface="Calibri"/>
+              </a:defRPr>
+            </a:pPr>
+            <a:r>
+              <a:t>Claude Enterprise</a:t>
+            </a:r>
+          </a:p>
+        </p:txBody>
+      </p:sp>
+      <p:sp>
+        <p:nvSpPr>
+          <p:cNvPr id="18" name="TextBox 17"/>
+          <p:cNvSpPr txBox="1"/>
+          <p:nvPr/>
+        </p:nvSpPr>
+        <p:spPr>
+          <a:xfrm>
+            <a:off x="1633575" y="2633472"/>
+            <a:ext cx="8924544" cy="128016"/>
+          </a:xfrm>
+          <a:prstGeom prst="rect">
+            <a:avLst/>
+          </a:prstGeom>
+          <a:noFill/>
+        </p:spPr>
+        <p:txBody>
+          <a:bodyPr wrap="square">
+            <a:spAutoFit/>
+          </a:bodyPr>
+          <a:lstStyle/>
+          <a:p>
+            <a:pPr algn="ctr">
+              <a:lnSpc>
+                <a:spcPct val="115000"/>
+              </a:lnSpc>
+              <a:defRPr sz="1100" b="0">
+                <a:solidFill>
+                  <a:srgbClr val="6B6B6B"/>
+                </a:solidFill>
+                <a:latin typeface="Calibri"/>
+              </a:defRPr>
+            </a:pPr>
+            <a:r>
+              <a:t>Document intelligence · Reasoning · Summarization</a:t>
+            </a:r>
+          </a:p>
+        </p:txBody>
+      </p:sp>
+      <p:sp>
+        <p:nvSpPr>
+          <p:cNvPr id="19" name="TextBox 18"/>
+          <p:cNvSpPr txBox="1"/>
+          <p:nvPr/>
+        </p:nvSpPr>
+        <p:spPr>
+          <a:xfrm>
+            <a:off x="5967831" y="2825496"/>
+            <a:ext cx="256032" cy="128016"/>
+          </a:xfrm>
+          <a:prstGeom prst="rect">
+            <a:avLst/>
+          </a:prstGeom>
+          <a:noFill/>
+        </p:spPr>
+        <p:txBody>
+          <a:bodyPr wrap="square">
+            <a:spAutoFit/>
+          </a:bodyPr>
+          <a:lstStyle/>
+          <a:p>
+            <a:pPr algn="ctr">
+              <a:lnSpc>
+                <a:spcPct val="115000"/>
+              </a:lnSpc>
+              <a:defRPr sz="1100" b="1">
+                <a:solidFill>
+                  <a:srgbClr val="E31837"/>
+                </a:solidFill>
+                <a:latin typeface="Calibri"/>
+              </a:defRPr>
+            </a:pPr>
+            <a:r>
+              <a:t>▼</a:t>
+            </a:r>
+          </a:p>
+        </p:txBody>
+      </p:sp>
+      <p:sp>
+        <p:nvSpPr>
+          <p:cNvPr id="20" name="Rounded Rectangle 19"/>
+          <p:cNvSpPr/>
+          <p:nvPr/>
+        </p:nvSpPr>
+        <p:spPr>
+          <a:xfrm>
+            <a:off x="1523847" y="2944368"/>
+            <a:ext cx="9144000" cy="530352"/>
+          </a:xfrm>
+          <a:prstGeom prst="roundRect">
+            <a:avLst/>
+          </a:prstGeom>
+          <a:solidFill>
+            <a:srgbClr val="FFFFFF"/>
+          </a:solidFill>
+          <a:ln w="9525">
+            <a:solidFill>
+              <a:srgbClr val="DDDDDD"/>
+            </a:solidFill>
+          </a:ln>
+        </p:spPr>
+        <p:style>
+          <a:lnRef idx="1">
+            <a:schemeClr val="accent1"/>
+          </a:lnRef>
+          <a:fillRef idx="3">
+            <a:schemeClr val="accent1"/>
+          </a:fillRef>
+          <a:effectRef idx="2">
+            <a:schemeClr val="accent1"/>
+          </a:effectRef>
+          <a:fontRef idx="minor">
+            <a:schemeClr val="lt1"/>
+          </a:fontRef>
+        </p:style>
+        <p:txBody>
+          <a:bodyPr rtlCol="0" anchor="ctr"/>
+          <a:lstStyle/>
+          <a:p>
+            <a:pPr algn="ctr"/>
+          </a:p>
+        </p:txBody>
+      </p:sp>
+      <p:sp>
+        <p:nvSpPr>
+          <p:cNvPr id="21" name="TextBox 20"/>
+          <p:cNvSpPr txBox="1"/>
+          <p:nvPr/>
+        </p:nvSpPr>
+        <p:spPr>
+          <a:xfrm>
+            <a:off x="1633575" y="3035808"/>
+            <a:ext cx="8924544" cy="256032"/>
+          </a:xfrm>
+          <a:prstGeom prst="rect">
+            <a:avLst/>
+          </a:prstGeom>
+          <a:noFill/>
+        </p:spPr>
+        <p:txBody>
+          <a:bodyPr wrap="square">
+            <a:spAutoFit/>
+          </a:bodyPr>
+          <a:lstStyle/>
+          <a:p>
+            <a:pPr algn="ctr">
+              <a:lnSpc>
+                <a:spcPct val="115000"/>
+              </a:lnSpc>
+              <a:defRPr sz="1100" b="1">
+                <a:solidFill>
+                  <a:srgbClr val="1A1A1A"/>
+                </a:solidFill>
+                <a:latin typeface="Calibri"/>
+              </a:defRPr>
+            </a:pPr>
+            <a:r>
+              <a:t>AI Orchestration Layer</a:t>
+            </a:r>
+          </a:p>
+        </p:txBody>
+      </p:sp>
+      <p:sp>
+        <p:nvSpPr>
+          <p:cNvPr id="22" name="TextBox 21"/>
+          <p:cNvSpPr txBox="1"/>
+          <p:nvPr/>
+        </p:nvSpPr>
+        <p:spPr>
+          <a:xfrm>
+            <a:off x="1633575" y="3291840"/>
+            <a:ext cx="8924544" cy="128016"/>
+          </a:xfrm>
+          <a:prstGeom prst="rect">
+            <a:avLst/>
+          </a:prstGeom>
+          <a:noFill/>
+        </p:spPr>
+        <p:txBody>
+          <a:bodyPr wrap="square">
+            <a:spAutoFit/>
+          </a:bodyPr>
+          <a:lstStyle/>
+          <a:p>
+            <a:pPr algn="ctr">
+              <a:lnSpc>
+                <a:spcPct val="115000"/>
+              </a:lnSpc>
+              <a:defRPr sz="1100" b="0">
+                <a:solidFill>
+                  <a:srgbClr val="6B6B6B"/>
+                </a:solidFill>
+                <a:latin typeface="Calibri"/>
+              </a:defRPr>
+            </a:pPr>
+            <a:r>
+              <a:t>Guardrails · Human-in-loop · Audit · Cost control</a:t>
+            </a:r>
+          </a:p>
+        </p:txBody>
+      </p:sp>
+      <p:sp>
+        <p:nvSpPr>
+          <p:cNvPr id="23" name="TextBox 22"/>
+          <p:cNvSpPr txBox="1"/>
+          <p:nvPr/>
+        </p:nvSpPr>
+        <p:spPr>
+          <a:xfrm>
+            <a:off x="5967831" y="3483864"/>
+            <a:ext cx="256032" cy="128016"/>
+          </a:xfrm>
+          <a:prstGeom prst="rect">
+            <a:avLst/>
+          </a:prstGeom>
+          <a:noFill/>
+        </p:spPr>
+        <p:txBody>
+          <a:bodyPr wrap="square">
+            <a:spAutoFit/>
+          </a:bodyPr>
+          <a:lstStyle/>
+          <a:p>
+            <a:pPr algn="ctr">
+              <a:lnSpc>
+                <a:spcPct val="115000"/>
+              </a:lnSpc>
+              <a:defRPr sz="1100" b="1">
+                <a:solidFill>
+                  <a:srgbClr val="E31837"/>
+                </a:solidFill>
+                <a:latin typeface="Calibri"/>
+              </a:defRPr>
+            </a:pPr>
+            <a:r>
+              <a:t>▼</a:t>
+            </a:r>
+          </a:p>
+        </p:txBody>
+      </p:sp>
+      <p:sp>
+        <p:nvSpPr>
+          <p:cNvPr id="24" name="Rounded Rectangle 23"/>
+          <p:cNvSpPr/>
+          <p:nvPr/>
+        </p:nvSpPr>
+        <p:spPr>
+          <a:xfrm>
+            <a:off x="1523847" y="3602736"/>
+            <a:ext cx="9144000" cy="530352"/>
+          </a:xfrm>
+          <a:prstGeom prst="roundRect">
+            <a:avLst/>
+          </a:prstGeom>
+          <a:solidFill>
+            <a:srgbClr val="FFFFFF"/>
+          </a:solidFill>
+          <a:ln w="9525">
+            <a:solidFill>
+              <a:srgbClr val="DDDDDD"/>
+            </a:solidFill>
+          </a:ln>
+        </p:spPr>
+        <p:style>
+          <a:lnRef idx="1">
+            <a:schemeClr val="accent1"/>
+          </a:lnRef>
+          <a:fillRef idx="3">
+            <a:schemeClr val="accent1"/>
+          </a:fillRef>
+          <a:effectRef idx="2">
+            <a:schemeClr val="accent1"/>
+          </a:effectRef>
+          <a:fontRef idx="minor">
+            <a:schemeClr val="lt1"/>
+          </a:fontRef>
+        </p:style>
+        <p:txBody>
+          <a:bodyPr rtlCol="0" anchor="ctr"/>
+          <a:lstStyle/>
+          <a:p>
+            <a:pPr algn="ctr"/>
+          </a:p>
+        </p:txBody>
+      </p:sp>
+      <p:sp>
+        <p:nvSpPr>
+          <p:cNvPr id="25" name="TextBox 24"/>
+          <p:cNvSpPr txBox="1"/>
+          <p:nvPr/>
+        </p:nvSpPr>
+        <p:spPr>
+          <a:xfrm>
+            <a:off x="1633575" y="3694176"/>
+            <a:ext cx="8924544" cy="256032"/>
+          </a:xfrm>
+          <a:prstGeom prst="rect">
+            <a:avLst/>
+          </a:prstGeom>
+          <a:noFill/>
+        </p:spPr>
+        <p:txBody>
+          <a:bodyPr wrap="square">
+            <a:spAutoFit/>
+          </a:bodyPr>
+          <a:lstStyle/>
+          <a:p>
+            <a:pPr algn="ctr">
+              <a:lnSpc>
+                <a:spcPct val="115000"/>
+              </a:lnSpc>
+              <a:defRPr sz="1100" b="1">
+                <a:solidFill>
+                  <a:srgbClr val="1A1A1A"/>
+                </a:solidFill>
+                <a:latin typeface="Calibri"/>
+              </a:defRPr>
+            </a:pPr>
+            <a:r>
+              <a:t>Enterprise Knowledge Layer</a:t>
+            </a:r>
+          </a:p>
+        </p:txBody>
+      </p:sp>
+      <p:sp>
+        <p:nvSpPr>
+          <p:cNvPr id="26" name="TextBox 25"/>
+          <p:cNvSpPr txBox="1"/>
+          <p:nvPr/>
+        </p:nvSpPr>
+        <p:spPr>
+          <a:xfrm>
+            <a:off x="1633575" y="3950208"/>
+            <a:ext cx="8924544" cy="128016"/>
+          </a:xfrm>
+          <a:prstGeom prst="rect">
+            <a:avLst/>
+          </a:prstGeom>
+          <a:noFill/>
+        </p:spPr>
+        <p:txBody>
+          <a:bodyPr wrap="square">
+            <a:spAutoFit/>
+          </a:bodyPr>
+          <a:lstStyle/>
+          <a:p>
+            <a:pPr algn="ctr">
+              <a:lnSpc>
+                <a:spcPct val="115000"/>
+              </a:lnSpc>
+              <a:defRPr sz="1100" b="0">
+                <a:solidFill>
+                  <a:srgbClr val="6B6B6B"/>
+                </a:solidFill>
+                <a:latin typeface="Calibri"/>
+              </a:defRPr>
+            </a:pPr>
+            <a:r>
+              <a:t>Vector DB · RAG · Ingestion · Versioning</a:t>
+            </a:r>
+          </a:p>
+        </p:txBody>
+      </p:sp>
+      <p:sp>
+        <p:nvSpPr>
+          <p:cNvPr id="27" name="TextBox 26"/>
+          <p:cNvSpPr txBox="1"/>
+          <p:nvPr/>
+        </p:nvSpPr>
+        <p:spPr>
+          <a:xfrm>
+            <a:off x="5967831" y="4142232"/>
+            <a:ext cx="256032" cy="128016"/>
+          </a:xfrm>
+          <a:prstGeom prst="rect">
+            <a:avLst/>
+          </a:prstGeom>
+          <a:noFill/>
+        </p:spPr>
+        <p:txBody>
+          <a:bodyPr wrap="square">
+            <a:spAutoFit/>
+          </a:bodyPr>
+          <a:lstStyle/>
+          <a:p>
+            <a:pPr algn="ctr">
+              <a:lnSpc>
+                <a:spcPct val="115000"/>
+              </a:lnSpc>
+              <a:defRPr sz="1100" b="1">
+                <a:solidFill>
+                  <a:srgbClr val="E31837"/>
+                </a:solidFill>
+                <a:latin typeface="Calibri"/>
+              </a:defRPr>
+            </a:pPr>
+            <a:r>
+              <a:t>▼</a:t>
+            </a:r>
+          </a:p>
+        </p:txBody>
+      </p:sp>
+      <p:sp>
+        <p:nvSpPr>
+          <p:cNvPr id="28" name="Rounded Rectangle 27"/>
+          <p:cNvSpPr/>
+          <p:nvPr/>
+        </p:nvSpPr>
+        <p:spPr>
+          <a:xfrm>
+            <a:off x="1523847" y="4261104"/>
+            <a:ext cx="9144000" cy="530352"/>
+          </a:xfrm>
+          <a:prstGeom prst="roundRect">
+            <a:avLst/>
+          </a:prstGeom>
+          <a:solidFill>
+            <a:srgbClr val="FFFFFF"/>
+          </a:solidFill>
+          <a:ln w="9525">
+            <a:solidFill>
+              <a:srgbClr val="DDDDDD"/>
+            </a:solidFill>
+          </a:ln>
+        </p:spPr>
+        <p:style>
+          <a:lnRef idx="1">
+            <a:schemeClr val="accent1"/>
+          </a:lnRef>
+          <a:fillRef idx="3">
+            <a:schemeClr val="accent1"/>
+          </a:fillRef>
+          <a:effectRef idx="2">
+            <a:schemeClr val="accent1"/>
+          </a:effectRef>
+          <a:fontRef idx="minor">
+            <a:schemeClr val="lt1"/>
+          </a:fontRef>
+        </p:style>
+        <p:txBody>
+          <a:bodyPr rtlCol="0" anchor="ctr"/>
+          <a:lstStyle/>
+          <a:p>
+            <a:pPr algn="ctr"/>
+          </a:p>
+        </p:txBody>
+      </p:sp>
+      <p:sp>
+        <p:nvSpPr>
+          <p:cNvPr id="29" name="TextBox 28"/>
+          <p:cNvSpPr txBox="1"/>
+          <p:nvPr/>
+        </p:nvSpPr>
+        <p:spPr>
+          <a:xfrm>
+            <a:off x="1633575" y="4352544"/>
+            <a:ext cx="8924544" cy="256032"/>
+          </a:xfrm>
+          <a:prstGeom prst="rect">
+            <a:avLst/>
+          </a:prstGeom>
+          <a:noFill/>
+        </p:spPr>
+        <p:txBody>
+          <a:bodyPr wrap="square">
+            <a:spAutoFit/>
+          </a:bodyPr>
+          <a:lstStyle/>
+          <a:p>
+            <a:pPr algn="ctr">
+              <a:lnSpc>
+                <a:spcPct val="115000"/>
+              </a:lnSpc>
+              <a:defRPr sz="1100" b="1">
+                <a:solidFill>
+                  <a:srgbClr val="1A1A1A"/>
+                </a:solidFill>
+                <a:latin typeface="Calibri"/>
+              </a:defRPr>
+            </a:pPr>
+            <a:r>
+              <a:t>API / Integration Layer</a:t>
+            </a:r>
+          </a:p>
+        </p:txBody>
+      </p:sp>
+      <p:sp>
+        <p:nvSpPr>
+          <p:cNvPr id="30" name="TextBox 29"/>
+          <p:cNvSpPr txBox="1"/>
+          <p:nvPr/>
+        </p:nvSpPr>
+        <p:spPr>
+          <a:xfrm>
+            <a:off x="1633575" y="4608576"/>
+            <a:ext cx="8924544" cy="128016"/>
+          </a:xfrm>
+          <a:prstGeom prst="rect">
+            <a:avLst/>
+          </a:prstGeom>
+          <a:noFill/>
+        </p:spPr>
+        <p:txBody>
+          <a:bodyPr wrap="square">
+            <a:spAutoFit/>
+          </a:bodyPr>
+          <a:lstStyle/>
+          <a:p>
+            <a:pPr algn="ctr">
+              <a:lnSpc>
+                <a:spcPct val="115000"/>
+              </a:lnSpc>
+              <a:defRPr sz="1100" b="0">
+                <a:solidFill>
+                  <a:srgbClr val="6B6B6B"/>
+                </a:solidFill>
+                <a:latin typeface="Calibri"/>
+              </a:defRPr>
+            </a:pPr>
+            <a:r>
+              <a:t>PMWeb APIs · ETL · Schema validation</a:t>
+            </a:r>
+          </a:p>
+        </p:txBody>
+      </p:sp>
+      <p:sp>
+        <p:nvSpPr>
+          <p:cNvPr id="31" name="TextBox 30"/>
+          <p:cNvSpPr txBox="1"/>
+          <p:nvPr/>
+        </p:nvSpPr>
+        <p:spPr>
+          <a:xfrm>
+            <a:off x="5967831" y="4800600"/>
+            <a:ext cx="256032" cy="128016"/>
+          </a:xfrm>
+          <a:prstGeom prst="rect">
+            <a:avLst/>
+          </a:prstGeom>
+          <a:noFill/>
+        </p:spPr>
+        <p:txBody>
+          <a:bodyPr wrap="square">
+            <a:spAutoFit/>
+          </a:bodyPr>
+          <a:lstStyle/>
+          <a:p>
+            <a:pPr algn="ctr">
+              <a:lnSpc>
+                <a:spcPct val="115000"/>
+              </a:lnSpc>
+              <a:defRPr sz="1100" b="1">
+                <a:solidFill>
+                  <a:srgbClr val="E31837"/>
+                </a:solidFill>
+                <a:latin typeface="Calibri"/>
+              </a:defRPr>
+            </a:pPr>
+            <a:r>
+              <a:t>▼</a:t>
+            </a:r>
+          </a:p>
+        </p:txBody>
+      </p:sp>
+      <p:sp>
+        <p:nvSpPr>
+          <p:cNvPr id="32" name="Rounded Rectangle 31"/>
+          <p:cNvSpPr/>
+          <p:nvPr/>
+        </p:nvSpPr>
+        <p:spPr>
+          <a:xfrm>
+            <a:off x="1523847" y="4919472"/>
+            <a:ext cx="9144000" cy="530352"/>
+          </a:xfrm>
+          <a:prstGeom prst="roundRect">
+            <a:avLst/>
+          </a:prstGeom>
+          <a:solidFill>
+            <a:srgbClr val="FFFFFF"/>
+          </a:solidFill>
+          <a:ln w="9525">
+            <a:solidFill>
+              <a:srgbClr val="DDDDDD"/>
+            </a:solidFill>
+          </a:ln>
+        </p:spPr>
+        <p:style>
+          <a:lnRef idx="1">
+            <a:schemeClr val="accent1"/>
+          </a:lnRef>
+          <a:fillRef idx="3">
+            <a:schemeClr val="accent1"/>
+          </a:fillRef>
+          <a:effectRef idx="2">
+            <a:schemeClr val="accent1"/>
+          </a:effectRef>
+          <a:fontRef idx="minor">
+            <a:schemeClr val="lt1"/>
+          </a:fontRef>
+        </p:style>
+        <p:txBody>
+          <a:bodyPr rtlCol="0" anchor="ctr"/>
+          <a:lstStyle/>
+          <a:p>
+            <a:pPr algn="ctr"/>
+          </a:p>
+        </p:txBody>
+      </p:sp>
+      <p:sp>
+        <p:nvSpPr>
+          <p:cNvPr id="33" name="TextBox 32"/>
+          <p:cNvSpPr txBox="1"/>
+          <p:nvPr/>
+        </p:nvSpPr>
+        <p:spPr>
+          <a:xfrm>
+            <a:off x="1633575" y="5010912"/>
+            <a:ext cx="8924544" cy="256032"/>
+          </a:xfrm>
+          <a:prstGeom prst="rect">
+            <a:avLst/>
+          </a:prstGeom>
+          <a:noFill/>
+        </p:spPr>
+        <p:txBody>
+          <a:bodyPr wrap="square">
+            <a:spAutoFit/>
+          </a:bodyPr>
+          <a:lstStyle/>
+          <a:p>
+            <a:pPr algn="ctr">
+              <a:lnSpc>
+                <a:spcPct val="115000"/>
+              </a:lnSpc>
+              <a:defRPr sz="1100" b="1">
+                <a:solidFill>
+                  <a:srgbClr val="1A1A1A"/>
+                </a:solidFill>
+                <a:latin typeface="Calibri"/>
+              </a:defRPr>
+            </a:pPr>
+            <a:r>
+              <a:t>PMWeb</a:t>
+            </a:r>
+          </a:p>
+        </p:txBody>
+      </p:sp>
+      <p:sp>
+        <p:nvSpPr>
+          <p:cNvPr id="34" name="TextBox 33"/>
+          <p:cNvSpPr txBox="1"/>
+          <p:nvPr/>
+        </p:nvSpPr>
+        <p:spPr>
+          <a:xfrm>
+            <a:off x="1633575" y="5266944"/>
+            <a:ext cx="8924544" cy="128016"/>
+          </a:xfrm>
+          <a:prstGeom prst="rect">
+            <a:avLst/>
+          </a:prstGeom>
+          <a:noFill/>
+        </p:spPr>
+        <p:txBody>
+          <a:bodyPr wrap="square">
+            <a:spAutoFit/>
+          </a:bodyPr>
+          <a:lstStyle/>
+          <a:p>
+            <a:pPr algn="ctr">
+              <a:lnSpc>
+                <a:spcPct val="115000"/>
+              </a:lnSpc>
+              <a:defRPr sz="1100" b="0">
+                <a:solidFill>
+                  <a:srgbClr val="6B6B6B"/>
+                </a:solidFill>
+                <a:latin typeface="Calibri"/>
+              </a:defRPr>
+            </a:pPr>
+            <a:r>
+              <a:t>System of record — contracts, tenders, projects</a:t>
+            </a:r>
+          </a:p>
+        </p:txBody>
+      </p:sp>
+      <p:sp>
+        <p:nvSpPr>
+          <p:cNvPr id="35" name="Rounded Rectangle 34"/>
+          <p:cNvSpPr/>
+          <p:nvPr/>
+        </p:nvSpPr>
+        <p:spPr>
+          <a:xfrm>
+            <a:off x="1523847" y="5504688"/>
+            <a:ext cx="9144000" cy="384048"/>
+          </a:xfrm>
+          <a:prstGeom prst="roundRect">
+            <a:avLst/>
+          </a:prstGeom>
+          <a:solidFill>
+            <a:srgbClr val="FDF2F4"/>
+          </a:solidFill>
+          <a:ln w="9525">
+            <a:solidFill>
+              <a:srgbClr val="E31837"/>
+            </a:solidFill>
+          </a:ln>
+        </p:spPr>
+        <p:style>
+          <a:lnRef idx="1">
+            <a:schemeClr val="accent1"/>
+          </a:lnRef>
+          <a:fillRef idx="3">
+            <a:schemeClr val="accent1"/>
+          </a:fillRef>
+          <a:effectRef idx="2">
+            <a:schemeClr val="accent1"/>
+          </a:effectRef>
+          <a:fontRef idx="minor">
+            <a:schemeClr val="lt1"/>
+          </a:fontRef>
+        </p:style>
+        <p:txBody>
+          <a:bodyPr rtlCol="0" anchor="ctr"/>
+          <a:lstStyle/>
+          <a:p>
+            <a:pPr algn="ctr"/>
+          </a:p>
+        </p:txBody>
+      </p:sp>
+      <p:sp>
+        <p:nvSpPr>
+          <p:cNvPr id="36" name="TextBox 35"/>
+          <p:cNvSpPr txBox="1"/>
+          <p:nvPr/>
+        </p:nvSpPr>
+        <p:spPr>
+          <a:xfrm>
+            <a:off x="1661007" y="5577840"/>
+            <a:ext cx="8869680" cy="256032"/>
+          </a:xfrm>
+          <a:prstGeom prst="rect">
+            <a:avLst/>
+          </a:prstGeom>
+          <a:noFill/>
+        </p:spPr>
+        <p:txBody>
+          <a:bodyPr wrap="square">
+            <a:spAutoFit/>
+          </a:bodyPr>
+          <a:lstStyle/>
+          <a:p>
+            <a:pPr algn="ctr">
+              <a:lnSpc>
+                <a:spcPct val="115000"/>
+              </a:lnSpc>
+              <a:defRPr sz="1100" b="1">
+                <a:solidFill>
+                  <a:srgbClr val="B01228"/>
+                </a:solidFill>
+                <a:latin typeface="Calibri"/>
+              </a:defRPr>
+            </a:pPr>
+            <a:r>
+              <a:t>RBAC · Audit Logs · Prompt Logging · Citations · Vector DB · RAG</a:t>
+            </a:r>
+          </a:p>
+        </p:txBody>
+      </p:sp>
     </p:spTree>
   </p:cSld>
   <p:clrMapOvr>
@@ -24846,8 +25925,8 @@
         </p:nvSpPr>
         <p:spPr>
           <a:xfrm>
-            <a:off x="576072" y="2423160"/>
-            <a:ext cx="2185416" cy="292608"/>
+            <a:off x="612648" y="2423160"/>
+            <a:ext cx="2112264" cy="256032"/>
           </a:xfrm>
           <a:prstGeom prst="rect">
             <a:avLst/>
@@ -24930,8 +26009,8 @@
         </p:nvSpPr>
         <p:spPr>
           <a:xfrm>
-            <a:off x="9079992" y="2423160"/>
-            <a:ext cx="2185416" cy="292608"/>
+            <a:off x="9116568" y="2423160"/>
+            <a:ext cx="2112264" cy="256032"/>
           </a:xfrm>
           <a:prstGeom prst="rect">
             <a:avLst/>
@@ -25014,8 +26093,8 @@
         </p:nvSpPr>
         <p:spPr>
           <a:xfrm>
-            <a:off x="576072" y="4526280"/>
-            <a:ext cx="2185416" cy="292608"/>
+            <a:off x="612648" y="4526280"/>
+            <a:ext cx="2112264" cy="256032"/>
           </a:xfrm>
           <a:prstGeom prst="rect">
             <a:avLst/>
@@ -25098,8 +26177,8 @@
         </p:nvSpPr>
         <p:spPr>
           <a:xfrm>
-            <a:off x="9079992" y="4526280"/>
-            <a:ext cx="2185416" cy="292608"/>
+            <a:off x="9116568" y="4526280"/>
+            <a:ext cx="2112264" cy="256032"/>
           </a:xfrm>
           <a:prstGeom prst="rect">
             <a:avLst/>
@@ -25182,8 +26261,8 @@
         </p:nvSpPr>
         <p:spPr>
           <a:xfrm>
-            <a:off x="2999232" y="5166360"/>
-            <a:ext cx="2185416" cy="292608"/>
+            <a:off x="3035808" y="5166360"/>
+            <a:ext cx="2112264" cy="256032"/>
           </a:xfrm>
           <a:prstGeom prst="rect">
             <a:avLst/>
@@ -25266,8 +26345,8 @@
         </p:nvSpPr>
         <p:spPr>
           <a:xfrm>
-            <a:off x="6565392" y="5166360"/>
-            <a:ext cx="2185416" cy="292608"/>
+            <a:off x="6601968" y="5166360"/>
+            <a:ext cx="2112264" cy="256032"/>
           </a:xfrm>
           <a:prstGeom prst="rect">
             <a:avLst/>

</xml_diff>

<commit_message>
Fix RAG and architecture slide alignment with native centered shapes
- Architecture: symmetric Claude highlight, centered stack and arrows
- RAG: replace PNG pipeline with native flow boxes and arrows
- 2x2 component grid aligned to content width with even gaps

Co-authored-by: vishnushankar9024 <vishnushankar9024@users.noreply.github.com>
</commit_message>
<xml_diff>
--- a/output/DAMAC_PMWeb_AI_Governance_Intelligence_Layer.pptx
+++ b/output/DAMAC_PMWeb_AI_Governance_Intelligence_Layer.pptx
@@ -8432,8 +8432,8 @@
         </p:nvSpPr>
         <p:spPr>
           <a:xfrm>
-            <a:off x="1572768" y="2258568"/>
-            <a:ext cx="3072384" cy="256032"/>
+            <a:off x="1591056" y="2249424"/>
+            <a:ext cx="3035808" cy="237744"/>
           </a:xfrm>
           <a:prstGeom prst="rect">
             <a:avLst/>
@@ -8555,8 +8555,8 @@
         </p:nvSpPr>
         <p:spPr>
           <a:xfrm>
-            <a:off x="1572768" y="3063240"/>
-            <a:ext cx="3072384" cy="256032"/>
+            <a:off x="1591056" y="3054096"/>
+            <a:ext cx="3035808" cy="237744"/>
           </a:xfrm>
           <a:prstGeom prst="rect">
             <a:avLst/>
@@ -8678,8 +8678,8 @@
         </p:nvSpPr>
         <p:spPr>
           <a:xfrm>
-            <a:off x="1572768" y="3867912"/>
-            <a:ext cx="3072384" cy="256032"/>
+            <a:off x="1591056" y="3858768"/>
+            <a:ext cx="3035808" cy="237744"/>
           </a:xfrm>
           <a:prstGeom prst="rect">
             <a:avLst/>
@@ -8924,8 +8924,8 @@
         </p:nvSpPr>
         <p:spPr>
           <a:xfrm>
-            <a:off x="6967728" y="2167128"/>
-            <a:ext cx="4078224" cy="256032"/>
+            <a:off x="6986016" y="2157984"/>
+            <a:ext cx="4041648" cy="237744"/>
           </a:xfrm>
           <a:prstGeom prst="rect">
             <a:avLst/>
@@ -9008,8 +9008,8 @@
         </p:nvSpPr>
         <p:spPr>
           <a:xfrm>
-            <a:off x="6967728" y="2734056"/>
-            <a:ext cx="4078224" cy="256032"/>
+            <a:off x="6986016" y="2724912"/>
+            <a:ext cx="4041648" cy="237744"/>
           </a:xfrm>
           <a:prstGeom prst="rect">
             <a:avLst/>
@@ -9092,8 +9092,8 @@
         </p:nvSpPr>
         <p:spPr>
           <a:xfrm>
-            <a:off x="6967728" y="3300984"/>
-            <a:ext cx="4078224" cy="256032"/>
+            <a:off x="6986016" y="3291840"/>
+            <a:ext cx="4041648" cy="237744"/>
           </a:xfrm>
           <a:prstGeom prst="rect">
             <a:avLst/>
@@ -9176,8 +9176,8 @@
         </p:nvSpPr>
         <p:spPr>
           <a:xfrm>
-            <a:off x="6967728" y="3867912"/>
-            <a:ext cx="4078224" cy="256032"/>
+            <a:off x="6986016" y="3858768"/>
+            <a:ext cx="4041648" cy="237744"/>
           </a:xfrm>
           <a:prstGeom prst="rect">
             <a:avLst/>
@@ -9224,7 +9224,7 @@
           <a:solidFill>
             <a:srgbClr val="FDF2F4"/>
           </a:solidFill>
-          <a:ln w="9525">
+          <a:ln w="25400">
             <a:solidFill>
               <a:srgbClr val="E31837"/>
             </a:solidFill>
@@ -9254,57 +9254,14 @@
       </p:sp>
       <p:sp>
         <p:nvSpPr>
-          <p:cNvPr id="34" name="Rectangle 33"/>
-          <p:cNvSpPr/>
-          <p:nvPr/>
-        </p:nvSpPr>
-        <p:spPr>
-          <a:xfrm>
-            <a:off x="6858000" y="4343400"/>
-            <a:ext cx="64008" cy="475488"/>
-          </a:xfrm>
-          <a:prstGeom prst="rect">
-            <a:avLst/>
-          </a:prstGeom>
-          <a:solidFill>
-            <a:srgbClr val="E31837"/>
-          </a:solidFill>
-          <a:ln>
-            <a:noFill/>
-          </a:ln>
-        </p:spPr>
-        <p:style>
-          <a:lnRef idx="1">
-            <a:schemeClr val="accent1"/>
-          </a:lnRef>
-          <a:fillRef idx="3">
-            <a:schemeClr val="accent1"/>
-          </a:fillRef>
-          <a:effectRef idx="2">
-            <a:schemeClr val="accent1"/>
-          </a:effectRef>
-          <a:fontRef idx="minor">
-            <a:schemeClr val="lt1"/>
-          </a:fontRef>
-        </p:style>
-        <p:txBody>
-          <a:bodyPr rtlCol="0" anchor="ctr"/>
-          <a:lstStyle/>
-          <a:p>
-            <a:pPr algn="ctr"/>
-          </a:p>
-        </p:txBody>
-      </p:sp>
-      <p:sp>
-        <p:nvSpPr>
-          <p:cNvPr id="35" name="TextBox 34"/>
-          <p:cNvSpPr txBox="1"/>
-          <p:nvPr/>
-        </p:nvSpPr>
-        <p:spPr>
-          <a:xfrm>
-            <a:off x="6967728" y="4434840"/>
-            <a:ext cx="4078224" cy="256032"/>
+          <p:cNvPr id="34" name="TextBox 33"/>
+          <p:cNvSpPr txBox="1"/>
+          <p:nvPr/>
+        </p:nvSpPr>
+        <p:spPr>
+          <a:xfrm>
+            <a:off x="6986016" y="4425696"/>
+            <a:ext cx="4041648" cy="237744"/>
           </a:xfrm>
           <a:prstGeom prst="rect">
             <a:avLst/>
@@ -10090,8 +10047,8 @@
         </p:nvSpPr>
         <p:spPr>
           <a:xfrm>
-            <a:off x="1523847" y="1627632"/>
-            <a:ext cx="9144000" cy="530352"/>
+            <a:off x="1706727" y="1609344"/>
+            <a:ext cx="8778240" cy="493776"/>
           </a:xfrm>
           <a:prstGeom prst="roundRect">
             <a:avLst/>
@@ -10135,8 +10092,8 @@
         </p:nvSpPr>
         <p:spPr>
           <a:xfrm>
-            <a:off x="1633575" y="1719072"/>
-            <a:ext cx="8924544" cy="256032"/>
+            <a:off x="1834743" y="1691640"/>
+            <a:ext cx="8522208" cy="237744"/>
           </a:xfrm>
           <a:prstGeom prst="rect">
             <a:avLst/>
@@ -10174,8 +10131,8 @@
         </p:nvSpPr>
         <p:spPr>
           <a:xfrm>
-            <a:off x="1633575" y="1975104"/>
-            <a:ext cx="8924544" cy="128016"/>
+            <a:off x="1834743" y="1938528"/>
+            <a:ext cx="8522208" cy="109728"/>
           </a:xfrm>
           <a:prstGeom prst="rect">
             <a:avLst/>
@@ -10207,40 +10164,44 @@
       </p:sp>
       <p:sp>
         <p:nvSpPr>
-          <p:cNvPr id="14" name="TextBox 13"/>
-          <p:cNvSpPr txBox="1"/>
-          <p:nvPr/>
-        </p:nvSpPr>
-        <p:spPr>
-          <a:xfrm>
-            <a:off x="5967831" y="2167128"/>
-            <a:ext cx="256032" cy="128016"/>
-          </a:xfrm>
-          <a:prstGeom prst="rect">
-            <a:avLst/>
-          </a:prstGeom>
-          <a:noFill/>
-        </p:spPr>
-        <p:txBody>
-          <a:bodyPr wrap="square">
-            <a:spAutoFit/>
-          </a:bodyPr>
-          <a:lstStyle/>
-          <a:p>
-            <a:pPr algn="ctr">
-              <a:lnSpc>
-                <a:spcPct val="115000"/>
-              </a:lnSpc>
-              <a:defRPr sz="1100" b="1">
-                <a:solidFill>
-                  <a:srgbClr val="E31837"/>
-                </a:solidFill>
-                <a:latin typeface="Calibri"/>
-              </a:defRPr>
-            </a:pPr>
-            <a:r>
-              <a:t>▼</a:t>
-            </a:r>
+          <p:cNvPr id="14" name="Isosceles Triangle 13"/>
+          <p:cNvSpPr/>
+          <p:nvPr/>
+        </p:nvSpPr>
+        <p:spPr>
+          <a:xfrm rot="10800000">
+            <a:off x="6022695" y="2112264"/>
+            <a:ext cx="146304" cy="91440"/>
+          </a:xfrm>
+          <a:prstGeom prst="triangle">
+            <a:avLst/>
+          </a:prstGeom>
+          <a:solidFill>
+            <a:srgbClr val="E31837"/>
+          </a:solidFill>
+          <a:ln>
+            <a:noFill/>
+          </a:ln>
+        </p:spPr>
+        <p:style>
+          <a:lnRef idx="1">
+            <a:schemeClr val="accent1"/>
+          </a:lnRef>
+          <a:fillRef idx="3">
+            <a:schemeClr val="accent1"/>
+          </a:fillRef>
+          <a:effectRef idx="2">
+            <a:schemeClr val="accent1"/>
+          </a:effectRef>
+          <a:fontRef idx="minor">
+            <a:schemeClr val="lt1"/>
+          </a:fontRef>
+        </p:style>
+        <p:txBody>
+          <a:bodyPr rtlCol="0" anchor="ctr"/>
+          <a:lstStyle/>
+          <a:p>
+            <a:pPr algn="ctr"/>
           </a:p>
         </p:txBody>
       </p:sp>
@@ -10252,8 +10213,795 @@
         </p:nvSpPr>
         <p:spPr>
           <a:xfrm>
-            <a:off x="1523847" y="2286000"/>
-            <a:ext cx="9144000" cy="530352"/>
+            <a:off x="1706727" y="2194560"/>
+            <a:ext cx="8778240" cy="493776"/>
+          </a:xfrm>
+          <a:prstGeom prst="roundRect">
+            <a:avLst/>
+          </a:prstGeom>
+          <a:solidFill>
+            <a:srgbClr val="FDF2F4"/>
+          </a:solidFill>
+          <a:ln w="25400">
+            <a:solidFill>
+              <a:srgbClr val="E31837"/>
+            </a:solidFill>
+          </a:ln>
+        </p:spPr>
+        <p:style>
+          <a:lnRef idx="1">
+            <a:schemeClr val="accent1"/>
+          </a:lnRef>
+          <a:fillRef idx="3">
+            <a:schemeClr val="accent1"/>
+          </a:fillRef>
+          <a:effectRef idx="2">
+            <a:schemeClr val="accent1"/>
+          </a:effectRef>
+          <a:fontRef idx="minor">
+            <a:schemeClr val="lt1"/>
+          </a:fontRef>
+        </p:style>
+        <p:txBody>
+          <a:bodyPr rtlCol="0" anchor="ctr"/>
+          <a:lstStyle/>
+          <a:p>
+            <a:pPr algn="ctr"/>
+          </a:p>
+        </p:txBody>
+      </p:sp>
+      <p:sp>
+        <p:nvSpPr>
+          <p:cNvPr id="16" name="TextBox 15"/>
+          <p:cNvSpPr txBox="1"/>
+          <p:nvPr/>
+        </p:nvSpPr>
+        <p:spPr>
+          <a:xfrm>
+            <a:off x="1834743" y="2276856"/>
+            <a:ext cx="8522208" cy="237744"/>
+          </a:xfrm>
+          <a:prstGeom prst="rect">
+            <a:avLst/>
+          </a:prstGeom>
+          <a:noFill/>
+        </p:spPr>
+        <p:txBody>
+          <a:bodyPr wrap="square">
+            <a:spAutoFit/>
+          </a:bodyPr>
+          <a:lstStyle/>
+          <a:p>
+            <a:pPr algn="ctr">
+              <a:lnSpc>
+                <a:spcPct val="115000"/>
+              </a:lnSpc>
+              <a:defRPr sz="1100" b="1">
+                <a:solidFill>
+                  <a:srgbClr val="B01228"/>
+                </a:solidFill>
+                <a:latin typeface="Calibri"/>
+              </a:defRPr>
+            </a:pPr>
+            <a:r>
+              <a:t>Claude Enterprise</a:t>
+            </a:r>
+          </a:p>
+        </p:txBody>
+      </p:sp>
+      <p:sp>
+        <p:nvSpPr>
+          <p:cNvPr id="17" name="TextBox 16"/>
+          <p:cNvSpPr txBox="1"/>
+          <p:nvPr/>
+        </p:nvSpPr>
+        <p:spPr>
+          <a:xfrm>
+            <a:off x="1834743" y="2523744"/>
+            <a:ext cx="8522208" cy="109728"/>
+          </a:xfrm>
+          <a:prstGeom prst="rect">
+            <a:avLst/>
+          </a:prstGeom>
+          <a:noFill/>
+        </p:spPr>
+        <p:txBody>
+          <a:bodyPr wrap="square">
+            <a:spAutoFit/>
+          </a:bodyPr>
+          <a:lstStyle/>
+          <a:p>
+            <a:pPr algn="ctr">
+              <a:lnSpc>
+                <a:spcPct val="115000"/>
+              </a:lnSpc>
+              <a:defRPr sz="1100" b="0">
+                <a:solidFill>
+                  <a:srgbClr val="6B6B6B"/>
+                </a:solidFill>
+                <a:latin typeface="Calibri"/>
+              </a:defRPr>
+            </a:pPr>
+            <a:r>
+              <a:t>Document intelligence · Reasoning · Summarization</a:t>
+            </a:r>
+          </a:p>
+        </p:txBody>
+      </p:sp>
+      <p:sp>
+        <p:nvSpPr>
+          <p:cNvPr id="18" name="Isosceles Triangle 17"/>
+          <p:cNvSpPr/>
+          <p:nvPr/>
+        </p:nvSpPr>
+        <p:spPr>
+          <a:xfrm rot="10800000">
+            <a:off x="6022695" y="2697480"/>
+            <a:ext cx="146304" cy="91440"/>
+          </a:xfrm>
+          <a:prstGeom prst="triangle">
+            <a:avLst/>
+          </a:prstGeom>
+          <a:solidFill>
+            <a:srgbClr val="E31837"/>
+          </a:solidFill>
+          <a:ln>
+            <a:noFill/>
+          </a:ln>
+        </p:spPr>
+        <p:style>
+          <a:lnRef idx="1">
+            <a:schemeClr val="accent1"/>
+          </a:lnRef>
+          <a:fillRef idx="3">
+            <a:schemeClr val="accent1"/>
+          </a:fillRef>
+          <a:effectRef idx="2">
+            <a:schemeClr val="accent1"/>
+          </a:effectRef>
+          <a:fontRef idx="minor">
+            <a:schemeClr val="lt1"/>
+          </a:fontRef>
+        </p:style>
+        <p:txBody>
+          <a:bodyPr rtlCol="0" anchor="ctr"/>
+          <a:lstStyle/>
+          <a:p>
+            <a:pPr algn="ctr"/>
+          </a:p>
+        </p:txBody>
+      </p:sp>
+      <p:sp>
+        <p:nvSpPr>
+          <p:cNvPr id="19" name="Rounded Rectangle 18"/>
+          <p:cNvSpPr/>
+          <p:nvPr/>
+        </p:nvSpPr>
+        <p:spPr>
+          <a:xfrm>
+            <a:off x="1706727" y="2779776"/>
+            <a:ext cx="8778240" cy="493776"/>
+          </a:xfrm>
+          <a:prstGeom prst="roundRect">
+            <a:avLst/>
+          </a:prstGeom>
+          <a:solidFill>
+            <a:srgbClr val="FFFFFF"/>
+          </a:solidFill>
+          <a:ln w="9525">
+            <a:solidFill>
+              <a:srgbClr val="DDDDDD"/>
+            </a:solidFill>
+          </a:ln>
+        </p:spPr>
+        <p:style>
+          <a:lnRef idx="1">
+            <a:schemeClr val="accent1"/>
+          </a:lnRef>
+          <a:fillRef idx="3">
+            <a:schemeClr val="accent1"/>
+          </a:fillRef>
+          <a:effectRef idx="2">
+            <a:schemeClr val="accent1"/>
+          </a:effectRef>
+          <a:fontRef idx="minor">
+            <a:schemeClr val="lt1"/>
+          </a:fontRef>
+        </p:style>
+        <p:txBody>
+          <a:bodyPr rtlCol="0" anchor="ctr"/>
+          <a:lstStyle/>
+          <a:p>
+            <a:pPr algn="ctr"/>
+          </a:p>
+        </p:txBody>
+      </p:sp>
+      <p:sp>
+        <p:nvSpPr>
+          <p:cNvPr id="20" name="TextBox 19"/>
+          <p:cNvSpPr txBox="1"/>
+          <p:nvPr/>
+        </p:nvSpPr>
+        <p:spPr>
+          <a:xfrm>
+            <a:off x="1834743" y="2862072"/>
+            <a:ext cx="8522208" cy="237744"/>
+          </a:xfrm>
+          <a:prstGeom prst="rect">
+            <a:avLst/>
+          </a:prstGeom>
+          <a:noFill/>
+        </p:spPr>
+        <p:txBody>
+          <a:bodyPr wrap="square">
+            <a:spAutoFit/>
+          </a:bodyPr>
+          <a:lstStyle/>
+          <a:p>
+            <a:pPr algn="ctr">
+              <a:lnSpc>
+                <a:spcPct val="115000"/>
+              </a:lnSpc>
+              <a:defRPr sz="1100" b="1">
+                <a:solidFill>
+                  <a:srgbClr val="1A1A1A"/>
+                </a:solidFill>
+                <a:latin typeface="Calibri"/>
+              </a:defRPr>
+            </a:pPr>
+            <a:r>
+              <a:t>AI Orchestration Layer</a:t>
+            </a:r>
+          </a:p>
+        </p:txBody>
+      </p:sp>
+      <p:sp>
+        <p:nvSpPr>
+          <p:cNvPr id="21" name="TextBox 20"/>
+          <p:cNvSpPr txBox="1"/>
+          <p:nvPr/>
+        </p:nvSpPr>
+        <p:spPr>
+          <a:xfrm>
+            <a:off x="1834743" y="3108960"/>
+            <a:ext cx="8522208" cy="109728"/>
+          </a:xfrm>
+          <a:prstGeom prst="rect">
+            <a:avLst/>
+          </a:prstGeom>
+          <a:noFill/>
+        </p:spPr>
+        <p:txBody>
+          <a:bodyPr wrap="square">
+            <a:spAutoFit/>
+          </a:bodyPr>
+          <a:lstStyle/>
+          <a:p>
+            <a:pPr algn="ctr">
+              <a:lnSpc>
+                <a:spcPct val="115000"/>
+              </a:lnSpc>
+              <a:defRPr sz="1100" b="0">
+                <a:solidFill>
+                  <a:srgbClr val="6B6B6B"/>
+                </a:solidFill>
+                <a:latin typeface="Calibri"/>
+              </a:defRPr>
+            </a:pPr>
+            <a:r>
+              <a:t>Guardrails · Human-in-loop · Audit · Cost control</a:t>
+            </a:r>
+          </a:p>
+        </p:txBody>
+      </p:sp>
+      <p:sp>
+        <p:nvSpPr>
+          <p:cNvPr id="22" name="Isosceles Triangle 21"/>
+          <p:cNvSpPr/>
+          <p:nvPr/>
+        </p:nvSpPr>
+        <p:spPr>
+          <a:xfrm rot="10800000">
+            <a:off x="6022695" y="3282696"/>
+            <a:ext cx="146304" cy="91440"/>
+          </a:xfrm>
+          <a:prstGeom prst="triangle">
+            <a:avLst/>
+          </a:prstGeom>
+          <a:solidFill>
+            <a:srgbClr val="E31837"/>
+          </a:solidFill>
+          <a:ln>
+            <a:noFill/>
+          </a:ln>
+        </p:spPr>
+        <p:style>
+          <a:lnRef idx="1">
+            <a:schemeClr val="accent1"/>
+          </a:lnRef>
+          <a:fillRef idx="3">
+            <a:schemeClr val="accent1"/>
+          </a:fillRef>
+          <a:effectRef idx="2">
+            <a:schemeClr val="accent1"/>
+          </a:effectRef>
+          <a:fontRef idx="minor">
+            <a:schemeClr val="lt1"/>
+          </a:fontRef>
+        </p:style>
+        <p:txBody>
+          <a:bodyPr rtlCol="0" anchor="ctr"/>
+          <a:lstStyle/>
+          <a:p>
+            <a:pPr algn="ctr"/>
+          </a:p>
+        </p:txBody>
+      </p:sp>
+      <p:sp>
+        <p:nvSpPr>
+          <p:cNvPr id="23" name="Rounded Rectangle 22"/>
+          <p:cNvSpPr/>
+          <p:nvPr/>
+        </p:nvSpPr>
+        <p:spPr>
+          <a:xfrm>
+            <a:off x="1706727" y="3364992"/>
+            <a:ext cx="8778240" cy="493776"/>
+          </a:xfrm>
+          <a:prstGeom prst="roundRect">
+            <a:avLst/>
+          </a:prstGeom>
+          <a:solidFill>
+            <a:srgbClr val="FFFFFF"/>
+          </a:solidFill>
+          <a:ln w="9525">
+            <a:solidFill>
+              <a:srgbClr val="DDDDDD"/>
+            </a:solidFill>
+          </a:ln>
+        </p:spPr>
+        <p:style>
+          <a:lnRef idx="1">
+            <a:schemeClr val="accent1"/>
+          </a:lnRef>
+          <a:fillRef idx="3">
+            <a:schemeClr val="accent1"/>
+          </a:fillRef>
+          <a:effectRef idx="2">
+            <a:schemeClr val="accent1"/>
+          </a:effectRef>
+          <a:fontRef idx="minor">
+            <a:schemeClr val="lt1"/>
+          </a:fontRef>
+        </p:style>
+        <p:txBody>
+          <a:bodyPr rtlCol="0" anchor="ctr"/>
+          <a:lstStyle/>
+          <a:p>
+            <a:pPr algn="ctr"/>
+          </a:p>
+        </p:txBody>
+      </p:sp>
+      <p:sp>
+        <p:nvSpPr>
+          <p:cNvPr id="24" name="TextBox 23"/>
+          <p:cNvSpPr txBox="1"/>
+          <p:nvPr/>
+        </p:nvSpPr>
+        <p:spPr>
+          <a:xfrm>
+            <a:off x="1834743" y="3447288"/>
+            <a:ext cx="8522208" cy="237744"/>
+          </a:xfrm>
+          <a:prstGeom prst="rect">
+            <a:avLst/>
+          </a:prstGeom>
+          <a:noFill/>
+        </p:spPr>
+        <p:txBody>
+          <a:bodyPr wrap="square">
+            <a:spAutoFit/>
+          </a:bodyPr>
+          <a:lstStyle/>
+          <a:p>
+            <a:pPr algn="ctr">
+              <a:lnSpc>
+                <a:spcPct val="115000"/>
+              </a:lnSpc>
+              <a:defRPr sz="1100" b="1">
+                <a:solidFill>
+                  <a:srgbClr val="1A1A1A"/>
+                </a:solidFill>
+                <a:latin typeface="Calibri"/>
+              </a:defRPr>
+            </a:pPr>
+            <a:r>
+              <a:t>Enterprise Knowledge Layer</a:t>
+            </a:r>
+          </a:p>
+        </p:txBody>
+      </p:sp>
+      <p:sp>
+        <p:nvSpPr>
+          <p:cNvPr id="25" name="TextBox 24"/>
+          <p:cNvSpPr txBox="1"/>
+          <p:nvPr/>
+        </p:nvSpPr>
+        <p:spPr>
+          <a:xfrm>
+            <a:off x="1834743" y="3694176"/>
+            <a:ext cx="8522208" cy="109728"/>
+          </a:xfrm>
+          <a:prstGeom prst="rect">
+            <a:avLst/>
+          </a:prstGeom>
+          <a:noFill/>
+        </p:spPr>
+        <p:txBody>
+          <a:bodyPr wrap="square">
+            <a:spAutoFit/>
+          </a:bodyPr>
+          <a:lstStyle/>
+          <a:p>
+            <a:pPr algn="ctr">
+              <a:lnSpc>
+                <a:spcPct val="115000"/>
+              </a:lnSpc>
+              <a:defRPr sz="1100" b="0">
+                <a:solidFill>
+                  <a:srgbClr val="6B6B6B"/>
+                </a:solidFill>
+                <a:latin typeface="Calibri"/>
+              </a:defRPr>
+            </a:pPr>
+            <a:r>
+              <a:t>Vector DB · RAG · Ingestion · Versioning</a:t>
+            </a:r>
+          </a:p>
+        </p:txBody>
+      </p:sp>
+      <p:sp>
+        <p:nvSpPr>
+          <p:cNvPr id="26" name="Isosceles Triangle 25"/>
+          <p:cNvSpPr/>
+          <p:nvPr/>
+        </p:nvSpPr>
+        <p:spPr>
+          <a:xfrm rot="10800000">
+            <a:off x="6022695" y="3867912"/>
+            <a:ext cx="146304" cy="91440"/>
+          </a:xfrm>
+          <a:prstGeom prst="triangle">
+            <a:avLst/>
+          </a:prstGeom>
+          <a:solidFill>
+            <a:srgbClr val="E31837"/>
+          </a:solidFill>
+          <a:ln>
+            <a:noFill/>
+          </a:ln>
+        </p:spPr>
+        <p:style>
+          <a:lnRef idx="1">
+            <a:schemeClr val="accent1"/>
+          </a:lnRef>
+          <a:fillRef idx="3">
+            <a:schemeClr val="accent1"/>
+          </a:fillRef>
+          <a:effectRef idx="2">
+            <a:schemeClr val="accent1"/>
+          </a:effectRef>
+          <a:fontRef idx="minor">
+            <a:schemeClr val="lt1"/>
+          </a:fontRef>
+        </p:style>
+        <p:txBody>
+          <a:bodyPr rtlCol="0" anchor="ctr"/>
+          <a:lstStyle/>
+          <a:p>
+            <a:pPr algn="ctr"/>
+          </a:p>
+        </p:txBody>
+      </p:sp>
+      <p:sp>
+        <p:nvSpPr>
+          <p:cNvPr id="27" name="Rounded Rectangle 26"/>
+          <p:cNvSpPr/>
+          <p:nvPr/>
+        </p:nvSpPr>
+        <p:spPr>
+          <a:xfrm>
+            <a:off x="1706727" y="3950208"/>
+            <a:ext cx="8778240" cy="493776"/>
+          </a:xfrm>
+          <a:prstGeom prst="roundRect">
+            <a:avLst/>
+          </a:prstGeom>
+          <a:solidFill>
+            <a:srgbClr val="FFFFFF"/>
+          </a:solidFill>
+          <a:ln w="9525">
+            <a:solidFill>
+              <a:srgbClr val="DDDDDD"/>
+            </a:solidFill>
+          </a:ln>
+        </p:spPr>
+        <p:style>
+          <a:lnRef idx="1">
+            <a:schemeClr val="accent1"/>
+          </a:lnRef>
+          <a:fillRef idx="3">
+            <a:schemeClr val="accent1"/>
+          </a:fillRef>
+          <a:effectRef idx="2">
+            <a:schemeClr val="accent1"/>
+          </a:effectRef>
+          <a:fontRef idx="minor">
+            <a:schemeClr val="lt1"/>
+          </a:fontRef>
+        </p:style>
+        <p:txBody>
+          <a:bodyPr rtlCol="0" anchor="ctr"/>
+          <a:lstStyle/>
+          <a:p>
+            <a:pPr algn="ctr"/>
+          </a:p>
+        </p:txBody>
+      </p:sp>
+      <p:sp>
+        <p:nvSpPr>
+          <p:cNvPr id="28" name="TextBox 27"/>
+          <p:cNvSpPr txBox="1"/>
+          <p:nvPr/>
+        </p:nvSpPr>
+        <p:spPr>
+          <a:xfrm>
+            <a:off x="1834743" y="4032504"/>
+            <a:ext cx="8522208" cy="237744"/>
+          </a:xfrm>
+          <a:prstGeom prst="rect">
+            <a:avLst/>
+          </a:prstGeom>
+          <a:noFill/>
+        </p:spPr>
+        <p:txBody>
+          <a:bodyPr wrap="square">
+            <a:spAutoFit/>
+          </a:bodyPr>
+          <a:lstStyle/>
+          <a:p>
+            <a:pPr algn="ctr">
+              <a:lnSpc>
+                <a:spcPct val="115000"/>
+              </a:lnSpc>
+              <a:defRPr sz="1100" b="1">
+                <a:solidFill>
+                  <a:srgbClr val="1A1A1A"/>
+                </a:solidFill>
+                <a:latin typeface="Calibri"/>
+              </a:defRPr>
+            </a:pPr>
+            <a:r>
+              <a:t>API / Integration Layer</a:t>
+            </a:r>
+          </a:p>
+        </p:txBody>
+      </p:sp>
+      <p:sp>
+        <p:nvSpPr>
+          <p:cNvPr id="29" name="TextBox 28"/>
+          <p:cNvSpPr txBox="1"/>
+          <p:nvPr/>
+        </p:nvSpPr>
+        <p:spPr>
+          <a:xfrm>
+            <a:off x="1834743" y="4279392"/>
+            <a:ext cx="8522208" cy="109728"/>
+          </a:xfrm>
+          <a:prstGeom prst="rect">
+            <a:avLst/>
+          </a:prstGeom>
+          <a:noFill/>
+        </p:spPr>
+        <p:txBody>
+          <a:bodyPr wrap="square">
+            <a:spAutoFit/>
+          </a:bodyPr>
+          <a:lstStyle/>
+          <a:p>
+            <a:pPr algn="ctr">
+              <a:lnSpc>
+                <a:spcPct val="115000"/>
+              </a:lnSpc>
+              <a:defRPr sz="1100" b="0">
+                <a:solidFill>
+                  <a:srgbClr val="6B6B6B"/>
+                </a:solidFill>
+                <a:latin typeface="Calibri"/>
+              </a:defRPr>
+            </a:pPr>
+            <a:r>
+              <a:t>PMWeb APIs · ETL · Schema validation</a:t>
+            </a:r>
+          </a:p>
+        </p:txBody>
+      </p:sp>
+      <p:sp>
+        <p:nvSpPr>
+          <p:cNvPr id="30" name="Isosceles Triangle 29"/>
+          <p:cNvSpPr/>
+          <p:nvPr/>
+        </p:nvSpPr>
+        <p:spPr>
+          <a:xfrm rot="10800000">
+            <a:off x="6022695" y="4453128"/>
+            <a:ext cx="146304" cy="91440"/>
+          </a:xfrm>
+          <a:prstGeom prst="triangle">
+            <a:avLst/>
+          </a:prstGeom>
+          <a:solidFill>
+            <a:srgbClr val="E31837"/>
+          </a:solidFill>
+          <a:ln>
+            <a:noFill/>
+          </a:ln>
+        </p:spPr>
+        <p:style>
+          <a:lnRef idx="1">
+            <a:schemeClr val="accent1"/>
+          </a:lnRef>
+          <a:fillRef idx="3">
+            <a:schemeClr val="accent1"/>
+          </a:fillRef>
+          <a:effectRef idx="2">
+            <a:schemeClr val="accent1"/>
+          </a:effectRef>
+          <a:fontRef idx="minor">
+            <a:schemeClr val="lt1"/>
+          </a:fontRef>
+        </p:style>
+        <p:txBody>
+          <a:bodyPr rtlCol="0" anchor="ctr"/>
+          <a:lstStyle/>
+          <a:p>
+            <a:pPr algn="ctr"/>
+          </a:p>
+        </p:txBody>
+      </p:sp>
+      <p:sp>
+        <p:nvSpPr>
+          <p:cNvPr id="31" name="Rounded Rectangle 30"/>
+          <p:cNvSpPr/>
+          <p:nvPr/>
+        </p:nvSpPr>
+        <p:spPr>
+          <a:xfrm>
+            <a:off x="1706727" y="4535424"/>
+            <a:ext cx="8778240" cy="493776"/>
+          </a:xfrm>
+          <a:prstGeom prst="roundRect">
+            <a:avLst/>
+          </a:prstGeom>
+          <a:solidFill>
+            <a:srgbClr val="FFFFFF"/>
+          </a:solidFill>
+          <a:ln w="9525">
+            <a:solidFill>
+              <a:srgbClr val="DDDDDD"/>
+            </a:solidFill>
+          </a:ln>
+        </p:spPr>
+        <p:style>
+          <a:lnRef idx="1">
+            <a:schemeClr val="accent1"/>
+          </a:lnRef>
+          <a:fillRef idx="3">
+            <a:schemeClr val="accent1"/>
+          </a:fillRef>
+          <a:effectRef idx="2">
+            <a:schemeClr val="accent1"/>
+          </a:effectRef>
+          <a:fontRef idx="minor">
+            <a:schemeClr val="lt1"/>
+          </a:fontRef>
+        </p:style>
+        <p:txBody>
+          <a:bodyPr rtlCol="0" anchor="ctr"/>
+          <a:lstStyle/>
+          <a:p>
+            <a:pPr algn="ctr"/>
+          </a:p>
+        </p:txBody>
+      </p:sp>
+      <p:sp>
+        <p:nvSpPr>
+          <p:cNvPr id="32" name="TextBox 31"/>
+          <p:cNvSpPr txBox="1"/>
+          <p:nvPr/>
+        </p:nvSpPr>
+        <p:spPr>
+          <a:xfrm>
+            <a:off x="1834743" y="4617720"/>
+            <a:ext cx="8522208" cy="237744"/>
+          </a:xfrm>
+          <a:prstGeom prst="rect">
+            <a:avLst/>
+          </a:prstGeom>
+          <a:noFill/>
+        </p:spPr>
+        <p:txBody>
+          <a:bodyPr wrap="square">
+            <a:spAutoFit/>
+          </a:bodyPr>
+          <a:lstStyle/>
+          <a:p>
+            <a:pPr algn="ctr">
+              <a:lnSpc>
+                <a:spcPct val="115000"/>
+              </a:lnSpc>
+              <a:defRPr sz="1100" b="1">
+                <a:solidFill>
+                  <a:srgbClr val="1A1A1A"/>
+                </a:solidFill>
+                <a:latin typeface="Calibri"/>
+              </a:defRPr>
+            </a:pPr>
+            <a:r>
+              <a:t>PMWeb</a:t>
+            </a:r>
+          </a:p>
+        </p:txBody>
+      </p:sp>
+      <p:sp>
+        <p:nvSpPr>
+          <p:cNvPr id="33" name="TextBox 32"/>
+          <p:cNvSpPr txBox="1"/>
+          <p:nvPr/>
+        </p:nvSpPr>
+        <p:spPr>
+          <a:xfrm>
+            <a:off x="1834743" y="4864608"/>
+            <a:ext cx="8522208" cy="109728"/>
+          </a:xfrm>
+          <a:prstGeom prst="rect">
+            <a:avLst/>
+          </a:prstGeom>
+          <a:noFill/>
+        </p:spPr>
+        <p:txBody>
+          <a:bodyPr wrap="square">
+            <a:spAutoFit/>
+          </a:bodyPr>
+          <a:lstStyle/>
+          <a:p>
+            <a:pPr algn="ctr">
+              <a:lnSpc>
+                <a:spcPct val="115000"/>
+              </a:lnSpc>
+              <a:defRPr sz="1100" b="0">
+                <a:solidFill>
+                  <a:srgbClr val="6B6B6B"/>
+                </a:solidFill>
+                <a:latin typeface="Calibri"/>
+              </a:defRPr>
+            </a:pPr>
+            <a:r>
+              <a:t>System of record — contracts, tenders, projects</a:t>
+            </a:r>
+          </a:p>
+        </p:txBody>
+      </p:sp>
+      <p:sp>
+        <p:nvSpPr>
+          <p:cNvPr id="34" name="Rounded Rectangle 33"/>
+          <p:cNvSpPr/>
+          <p:nvPr/>
+        </p:nvSpPr>
+        <p:spPr>
+          <a:xfrm>
+            <a:off x="1706727" y="5084064"/>
+            <a:ext cx="8778240" cy="365760"/>
           </a:xfrm>
           <a:prstGeom prst="roundRect">
             <a:avLst/>
@@ -10291,828 +11039,14 @@
       </p:sp>
       <p:sp>
         <p:nvSpPr>
-          <p:cNvPr id="16" name="Rectangle 15"/>
-          <p:cNvSpPr/>
-          <p:nvPr/>
-        </p:nvSpPr>
-        <p:spPr>
-          <a:xfrm>
-            <a:off x="1523847" y="2286000"/>
-            <a:ext cx="64008" cy="530352"/>
-          </a:xfrm>
-          <a:prstGeom prst="rect">
-            <a:avLst/>
-          </a:prstGeom>
-          <a:solidFill>
-            <a:srgbClr val="E31837"/>
-          </a:solidFill>
-          <a:ln>
-            <a:noFill/>
-          </a:ln>
-        </p:spPr>
-        <p:style>
-          <a:lnRef idx="1">
-            <a:schemeClr val="accent1"/>
-          </a:lnRef>
-          <a:fillRef idx="3">
-            <a:schemeClr val="accent1"/>
-          </a:fillRef>
-          <a:effectRef idx="2">
-            <a:schemeClr val="accent1"/>
-          </a:effectRef>
-          <a:fontRef idx="minor">
-            <a:schemeClr val="lt1"/>
-          </a:fontRef>
-        </p:style>
-        <p:txBody>
-          <a:bodyPr rtlCol="0" anchor="ctr"/>
-          <a:lstStyle/>
-          <a:p>
-            <a:pPr algn="ctr"/>
-          </a:p>
-        </p:txBody>
-      </p:sp>
-      <p:sp>
-        <p:nvSpPr>
-          <p:cNvPr id="17" name="TextBox 16"/>
-          <p:cNvSpPr txBox="1"/>
-          <p:nvPr/>
-        </p:nvSpPr>
-        <p:spPr>
-          <a:xfrm>
-            <a:off x="1633575" y="2377440"/>
-            <a:ext cx="8924544" cy="256032"/>
-          </a:xfrm>
-          <a:prstGeom prst="rect">
-            <a:avLst/>
-          </a:prstGeom>
-          <a:noFill/>
-        </p:spPr>
-        <p:txBody>
-          <a:bodyPr wrap="square">
-            <a:spAutoFit/>
-          </a:bodyPr>
-          <a:lstStyle/>
-          <a:p>
-            <a:pPr algn="ctr">
-              <a:lnSpc>
-                <a:spcPct val="115000"/>
-              </a:lnSpc>
-              <a:defRPr sz="1100" b="1">
-                <a:solidFill>
-                  <a:srgbClr val="B01228"/>
-                </a:solidFill>
-                <a:latin typeface="Calibri"/>
-              </a:defRPr>
-            </a:pPr>
-            <a:r>
-              <a:t>Claude Enterprise</a:t>
-            </a:r>
-          </a:p>
-        </p:txBody>
-      </p:sp>
-      <p:sp>
-        <p:nvSpPr>
-          <p:cNvPr id="18" name="TextBox 17"/>
-          <p:cNvSpPr txBox="1"/>
-          <p:nvPr/>
-        </p:nvSpPr>
-        <p:spPr>
-          <a:xfrm>
-            <a:off x="1633575" y="2633472"/>
-            <a:ext cx="8924544" cy="128016"/>
-          </a:xfrm>
-          <a:prstGeom prst="rect">
-            <a:avLst/>
-          </a:prstGeom>
-          <a:noFill/>
-        </p:spPr>
-        <p:txBody>
-          <a:bodyPr wrap="square">
-            <a:spAutoFit/>
-          </a:bodyPr>
-          <a:lstStyle/>
-          <a:p>
-            <a:pPr algn="ctr">
-              <a:lnSpc>
-                <a:spcPct val="115000"/>
-              </a:lnSpc>
-              <a:defRPr sz="1100" b="0">
-                <a:solidFill>
-                  <a:srgbClr val="6B6B6B"/>
-                </a:solidFill>
-                <a:latin typeface="Calibri"/>
-              </a:defRPr>
-            </a:pPr>
-            <a:r>
-              <a:t>Document intelligence · Reasoning · Summarization</a:t>
-            </a:r>
-          </a:p>
-        </p:txBody>
-      </p:sp>
-      <p:sp>
-        <p:nvSpPr>
-          <p:cNvPr id="19" name="TextBox 18"/>
-          <p:cNvSpPr txBox="1"/>
-          <p:nvPr/>
-        </p:nvSpPr>
-        <p:spPr>
-          <a:xfrm>
-            <a:off x="5967831" y="2825496"/>
-            <a:ext cx="256032" cy="128016"/>
-          </a:xfrm>
-          <a:prstGeom prst="rect">
-            <a:avLst/>
-          </a:prstGeom>
-          <a:noFill/>
-        </p:spPr>
-        <p:txBody>
-          <a:bodyPr wrap="square">
-            <a:spAutoFit/>
-          </a:bodyPr>
-          <a:lstStyle/>
-          <a:p>
-            <a:pPr algn="ctr">
-              <a:lnSpc>
-                <a:spcPct val="115000"/>
-              </a:lnSpc>
-              <a:defRPr sz="1100" b="1">
-                <a:solidFill>
-                  <a:srgbClr val="E31837"/>
-                </a:solidFill>
-                <a:latin typeface="Calibri"/>
-              </a:defRPr>
-            </a:pPr>
-            <a:r>
-              <a:t>▼</a:t>
-            </a:r>
-          </a:p>
-        </p:txBody>
-      </p:sp>
-      <p:sp>
-        <p:nvSpPr>
-          <p:cNvPr id="20" name="Rounded Rectangle 19"/>
-          <p:cNvSpPr/>
-          <p:nvPr/>
-        </p:nvSpPr>
-        <p:spPr>
-          <a:xfrm>
-            <a:off x="1523847" y="2944368"/>
-            <a:ext cx="9144000" cy="530352"/>
-          </a:xfrm>
-          <a:prstGeom prst="roundRect">
-            <a:avLst/>
-          </a:prstGeom>
-          <a:solidFill>
-            <a:srgbClr val="FFFFFF"/>
-          </a:solidFill>
-          <a:ln w="9525">
-            <a:solidFill>
-              <a:srgbClr val="DDDDDD"/>
-            </a:solidFill>
-          </a:ln>
-        </p:spPr>
-        <p:style>
-          <a:lnRef idx="1">
-            <a:schemeClr val="accent1"/>
-          </a:lnRef>
-          <a:fillRef idx="3">
-            <a:schemeClr val="accent1"/>
-          </a:fillRef>
-          <a:effectRef idx="2">
-            <a:schemeClr val="accent1"/>
-          </a:effectRef>
-          <a:fontRef idx="minor">
-            <a:schemeClr val="lt1"/>
-          </a:fontRef>
-        </p:style>
-        <p:txBody>
-          <a:bodyPr rtlCol="0" anchor="ctr"/>
-          <a:lstStyle/>
-          <a:p>
-            <a:pPr algn="ctr"/>
-          </a:p>
-        </p:txBody>
-      </p:sp>
-      <p:sp>
-        <p:nvSpPr>
-          <p:cNvPr id="21" name="TextBox 20"/>
-          <p:cNvSpPr txBox="1"/>
-          <p:nvPr/>
-        </p:nvSpPr>
-        <p:spPr>
-          <a:xfrm>
-            <a:off x="1633575" y="3035808"/>
-            <a:ext cx="8924544" cy="256032"/>
-          </a:xfrm>
-          <a:prstGeom prst="rect">
-            <a:avLst/>
-          </a:prstGeom>
-          <a:noFill/>
-        </p:spPr>
-        <p:txBody>
-          <a:bodyPr wrap="square">
-            <a:spAutoFit/>
-          </a:bodyPr>
-          <a:lstStyle/>
-          <a:p>
-            <a:pPr algn="ctr">
-              <a:lnSpc>
-                <a:spcPct val="115000"/>
-              </a:lnSpc>
-              <a:defRPr sz="1100" b="1">
-                <a:solidFill>
-                  <a:srgbClr val="1A1A1A"/>
-                </a:solidFill>
-                <a:latin typeface="Calibri"/>
-              </a:defRPr>
-            </a:pPr>
-            <a:r>
-              <a:t>AI Orchestration Layer</a:t>
-            </a:r>
-          </a:p>
-        </p:txBody>
-      </p:sp>
-      <p:sp>
-        <p:nvSpPr>
-          <p:cNvPr id="22" name="TextBox 21"/>
-          <p:cNvSpPr txBox="1"/>
-          <p:nvPr/>
-        </p:nvSpPr>
-        <p:spPr>
-          <a:xfrm>
-            <a:off x="1633575" y="3291840"/>
-            <a:ext cx="8924544" cy="128016"/>
-          </a:xfrm>
-          <a:prstGeom prst="rect">
-            <a:avLst/>
-          </a:prstGeom>
-          <a:noFill/>
-        </p:spPr>
-        <p:txBody>
-          <a:bodyPr wrap="square">
-            <a:spAutoFit/>
-          </a:bodyPr>
-          <a:lstStyle/>
-          <a:p>
-            <a:pPr algn="ctr">
-              <a:lnSpc>
-                <a:spcPct val="115000"/>
-              </a:lnSpc>
-              <a:defRPr sz="1100" b="0">
-                <a:solidFill>
-                  <a:srgbClr val="6B6B6B"/>
-                </a:solidFill>
-                <a:latin typeface="Calibri"/>
-              </a:defRPr>
-            </a:pPr>
-            <a:r>
-              <a:t>Guardrails · Human-in-loop · Audit · Cost control</a:t>
-            </a:r>
-          </a:p>
-        </p:txBody>
-      </p:sp>
-      <p:sp>
-        <p:nvSpPr>
-          <p:cNvPr id="23" name="TextBox 22"/>
-          <p:cNvSpPr txBox="1"/>
-          <p:nvPr/>
-        </p:nvSpPr>
-        <p:spPr>
-          <a:xfrm>
-            <a:off x="5967831" y="3483864"/>
-            <a:ext cx="256032" cy="128016"/>
-          </a:xfrm>
-          <a:prstGeom prst="rect">
-            <a:avLst/>
-          </a:prstGeom>
-          <a:noFill/>
-        </p:spPr>
-        <p:txBody>
-          <a:bodyPr wrap="square">
-            <a:spAutoFit/>
-          </a:bodyPr>
-          <a:lstStyle/>
-          <a:p>
-            <a:pPr algn="ctr">
-              <a:lnSpc>
-                <a:spcPct val="115000"/>
-              </a:lnSpc>
-              <a:defRPr sz="1100" b="1">
-                <a:solidFill>
-                  <a:srgbClr val="E31837"/>
-                </a:solidFill>
-                <a:latin typeface="Calibri"/>
-              </a:defRPr>
-            </a:pPr>
-            <a:r>
-              <a:t>▼</a:t>
-            </a:r>
-          </a:p>
-        </p:txBody>
-      </p:sp>
-      <p:sp>
-        <p:nvSpPr>
-          <p:cNvPr id="24" name="Rounded Rectangle 23"/>
-          <p:cNvSpPr/>
-          <p:nvPr/>
-        </p:nvSpPr>
-        <p:spPr>
-          <a:xfrm>
-            <a:off x="1523847" y="3602736"/>
-            <a:ext cx="9144000" cy="530352"/>
-          </a:xfrm>
-          <a:prstGeom prst="roundRect">
-            <a:avLst/>
-          </a:prstGeom>
-          <a:solidFill>
-            <a:srgbClr val="FFFFFF"/>
-          </a:solidFill>
-          <a:ln w="9525">
-            <a:solidFill>
-              <a:srgbClr val="DDDDDD"/>
-            </a:solidFill>
-          </a:ln>
-        </p:spPr>
-        <p:style>
-          <a:lnRef idx="1">
-            <a:schemeClr val="accent1"/>
-          </a:lnRef>
-          <a:fillRef idx="3">
-            <a:schemeClr val="accent1"/>
-          </a:fillRef>
-          <a:effectRef idx="2">
-            <a:schemeClr val="accent1"/>
-          </a:effectRef>
-          <a:fontRef idx="minor">
-            <a:schemeClr val="lt1"/>
-          </a:fontRef>
-        </p:style>
-        <p:txBody>
-          <a:bodyPr rtlCol="0" anchor="ctr"/>
-          <a:lstStyle/>
-          <a:p>
-            <a:pPr algn="ctr"/>
-          </a:p>
-        </p:txBody>
-      </p:sp>
-      <p:sp>
-        <p:nvSpPr>
-          <p:cNvPr id="25" name="TextBox 24"/>
-          <p:cNvSpPr txBox="1"/>
-          <p:nvPr/>
-        </p:nvSpPr>
-        <p:spPr>
-          <a:xfrm>
-            <a:off x="1633575" y="3694176"/>
-            <a:ext cx="8924544" cy="256032"/>
-          </a:xfrm>
-          <a:prstGeom prst="rect">
-            <a:avLst/>
-          </a:prstGeom>
-          <a:noFill/>
-        </p:spPr>
-        <p:txBody>
-          <a:bodyPr wrap="square">
-            <a:spAutoFit/>
-          </a:bodyPr>
-          <a:lstStyle/>
-          <a:p>
-            <a:pPr algn="ctr">
-              <a:lnSpc>
-                <a:spcPct val="115000"/>
-              </a:lnSpc>
-              <a:defRPr sz="1100" b="1">
-                <a:solidFill>
-                  <a:srgbClr val="1A1A1A"/>
-                </a:solidFill>
-                <a:latin typeface="Calibri"/>
-              </a:defRPr>
-            </a:pPr>
-            <a:r>
-              <a:t>Enterprise Knowledge Layer</a:t>
-            </a:r>
-          </a:p>
-        </p:txBody>
-      </p:sp>
-      <p:sp>
-        <p:nvSpPr>
-          <p:cNvPr id="26" name="TextBox 25"/>
-          <p:cNvSpPr txBox="1"/>
-          <p:nvPr/>
-        </p:nvSpPr>
-        <p:spPr>
-          <a:xfrm>
-            <a:off x="1633575" y="3950208"/>
-            <a:ext cx="8924544" cy="128016"/>
-          </a:xfrm>
-          <a:prstGeom prst="rect">
-            <a:avLst/>
-          </a:prstGeom>
-          <a:noFill/>
-        </p:spPr>
-        <p:txBody>
-          <a:bodyPr wrap="square">
-            <a:spAutoFit/>
-          </a:bodyPr>
-          <a:lstStyle/>
-          <a:p>
-            <a:pPr algn="ctr">
-              <a:lnSpc>
-                <a:spcPct val="115000"/>
-              </a:lnSpc>
-              <a:defRPr sz="1100" b="0">
-                <a:solidFill>
-                  <a:srgbClr val="6B6B6B"/>
-                </a:solidFill>
-                <a:latin typeface="Calibri"/>
-              </a:defRPr>
-            </a:pPr>
-            <a:r>
-              <a:t>Vector DB · RAG · Ingestion · Versioning</a:t>
-            </a:r>
-          </a:p>
-        </p:txBody>
-      </p:sp>
-      <p:sp>
-        <p:nvSpPr>
-          <p:cNvPr id="27" name="TextBox 26"/>
-          <p:cNvSpPr txBox="1"/>
-          <p:nvPr/>
-        </p:nvSpPr>
-        <p:spPr>
-          <a:xfrm>
-            <a:off x="5967831" y="4142232"/>
-            <a:ext cx="256032" cy="128016"/>
-          </a:xfrm>
-          <a:prstGeom prst="rect">
-            <a:avLst/>
-          </a:prstGeom>
-          <a:noFill/>
-        </p:spPr>
-        <p:txBody>
-          <a:bodyPr wrap="square">
-            <a:spAutoFit/>
-          </a:bodyPr>
-          <a:lstStyle/>
-          <a:p>
-            <a:pPr algn="ctr">
-              <a:lnSpc>
-                <a:spcPct val="115000"/>
-              </a:lnSpc>
-              <a:defRPr sz="1100" b="1">
-                <a:solidFill>
-                  <a:srgbClr val="E31837"/>
-                </a:solidFill>
-                <a:latin typeface="Calibri"/>
-              </a:defRPr>
-            </a:pPr>
-            <a:r>
-              <a:t>▼</a:t>
-            </a:r>
-          </a:p>
-        </p:txBody>
-      </p:sp>
-      <p:sp>
-        <p:nvSpPr>
-          <p:cNvPr id="28" name="Rounded Rectangle 27"/>
-          <p:cNvSpPr/>
-          <p:nvPr/>
-        </p:nvSpPr>
-        <p:spPr>
-          <a:xfrm>
-            <a:off x="1523847" y="4261104"/>
-            <a:ext cx="9144000" cy="530352"/>
-          </a:xfrm>
-          <a:prstGeom prst="roundRect">
-            <a:avLst/>
-          </a:prstGeom>
-          <a:solidFill>
-            <a:srgbClr val="FFFFFF"/>
-          </a:solidFill>
-          <a:ln w="9525">
-            <a:solidFill>
-              <a:srgbClr val="DDDDDD"/>
-            </a:solidFill>
-          </a:ln>
-        </p:spPr>
-        <p:style>
-          <a:lnRef idx="1">
-            <a:schemeClr val="accent1"/>
-          </a:lnRef>
-          <a:fillRef idx="3">
-            <a:schemeClr val="accent1"/>
-          </a:fillRef>
-          <a:effectRef idx="2">
-            <a:schemeClr val="accent1"/>
-          </a:effectRef>
-          <a:fontRef idx="minor">
-            <a:schemeClr val="lt1"/>
-          </a:fontRef>
-        </p:style>
-        <p:txBody>
-          <a:bodyPr rtlCol="0" anchor="ctr"/>
-          <a:lstStyle/>
-          <a:p>
-            <a:pPr algn="ctr"/>
-          </a:p>
-        </p:txBody>
-      </p:sp>
-      <p:sp>
-        <p:nvSpPr>
-          <p:cNvPr id="29" name="TextBox 28"/>
-          <p:cNvSpPr txBox="1"/>
-          <p:nvPr/>
-        </p:nvSpPr>
-        <p:spPr>
-          <a:xfrm>
-            <a:off x="1633575" y="4352544"/>
-            <a:ext cx="8924544" cy="256032"/>
-          </a:xfrm>
-          <a:prstGeom prst="rect">
-            <a:avLst/>
-          </a:prstGeom>
-          <a:noFill/>
-        </p:spPr>
-        <p:txBody>
-          <a:bodyPr wrap="square">
-            <a:spAutoFit/>
-          </a:bodyPr>
-          <a:lstStyle/>
-          <a:p>
-            <a:pPr algn="ctr">
-              <a:lnSpc>
-                <a:spcPct val="115000"/>
-              </a:lnSpc>
-              <a:defRPr sz="1100" b="1">
-                <a:solidFill>
-                  <a:srgbClr val="1A1A1A"/>
-                </a:solidFill>
-                <a:latin typeface="Calibri"/>
-              </a:defRPr>
-            </a:pPr>
-            <a:r>
-              <a:t>API / Integration Layer</a:t>
-            </a:r>
-          </a:p>
-        </p:txBody>
-      </p:sp>
-      <p:sp>
-        <p:nvSpPr>
-          <p:cNvPr id="30" name="TextBox 29"/>
-          <p:cNvSpPr txBox="1"/>
-          <p:nvPr/>
-        </p:nvSpPr>
-        <p:spPr>
-          <a:xfrm>
-            <a:off x="1633575" y="4608576"/>
-            <a:ext cx="8924544" cy="128016"/>
-          </a:xfrm>
-          <a:prstGeom prst="rect">
-            <a:avLst/>
-          </a:prstGeom>
-          <a:noFill/>
-        </p:spPr>
-        <p:txBody>
-          <a:bodyPr wrap="square">
-            <a:spAutoFit/>
-          </a:bodyPr>
-          <a:lstStyle/>
-          <a:p>
-            <a:pPr algn="ctr">
-              <a:lnSpc>
-                <a:spcPct val="115000"/>
-              </a:lnSpc>
-              <a:defRPr sz="1100" b="0">
-                <a:solidFill>
-                  <a:srgbClr val="6B6B6B"/>
-                </a:solidFill>
-                <a:latin typeface="Calibri"/>
-              </a:defRPr>
-            </a:pPr>
-            <a:r>
-              <a:t>PMWeb APIs · ETL · Schema validation</a:t>
-            </a:r>
-          </a:p>
-        </p:txBody>
-      </p:sp>
-      <p:sp>
-        <p:nvSpPr>
-          <p:cNvPr id="31" name="TextBox 30"/>
-          <p:cNvSpPr txBox="1"/>
-          <p:nvPr/>
-        </p:nvSpPr>
-        <p:spPr>
-          <a:xfrm>
-            <a:off x="5967831" y="4800600"/>
-            <a:ext cx="256032" cy="128016"/>
-          </a:xfrm>
-          <a:prstGeom prst="rect">
-            <a:avLst/>
-          </a:prstGeom>
-          <a:noFill/>
-        </p:spPr>
-        <p:txBody>
-          <a:bodyPr wrap="square">
-            <a:spAutoFit/>
-          </a:bodyPr>
-          <a:lstStyle/>
-          <a:p>
-            <a:pPr algn="ctr">
-              <a:lnSpc>
-                <a:spcPct val="115000"/>
-              </a:lnSpc>
-              <a:defRPr sz="1100" b="1">
-                <a:solidFill>
-                  <a:srgbClr val="E31837"/>
-                </a:solidFill>
-                <a:latin typeface="Calibri"/>
-              </a:defRPr>
-            </a:pPr>
-            <a:r>
-              <a:t>▼</a:t>
-            </a:r>
-          </a:p>
-        </p:txBody>
-      </p:sp>
-      <p:sp>
-        <p:nvSpPr>
-          <p:cNvPr id="32" name="Rounded Rectangle 31"/>
-          <p:cNvSpPr/>
-          <p:nvPr/>
-        </p:nvSpPr>
-        <p:spPr>
-          <a:xfrm>
-            <a:off x="1523847" y="4919472"/>
-            <a:ext cx="9144000" cy="530352"/>
-          </a:xfrm>
-          <a:prstGeom prst="roundRect">
-            <a:avLst/>
-          </a:prstGeom>
-          <a:solidFill>
-            <a:srgbClr val="FFFFFF"/>
-          </a:solidFill>
-          <a:ln w="9525">
-            <a:solidFill>
-              <a:srgbClr val="DDDDDD"/>
-            </a:solidFill>
-          </a:ln>
-        </p:spPr>
-        <p:style>
-          <a:lnRef idx="1">
-            <a:schemeClr val="accent1"/>
-          </a:lnRef>
-          <a:fillRef idx="3">
-            <a:schemeClr val="accent1"/>
-          </a:fillRef>
-          <a:effectRef idx="2">
-            <a:schemeClr val="accent1"/>
-          </a:effectRef>
-          <a:fontRef idx="minor">
-            <a:schemeClr val="lt1"/>
-          </a:fontRef>
-        </p:style>
-        <p:txBody>
-          <a:bodyPr rtlCol="0" anchor="ctr"/>
-          <a:lstStyle/>
-          <a:p>
-            <a:pPr algn="ctr"/>
-          </a:p>
-        </p:txBody>
-      </p:sp>
-      <p:sp>
-        <p:nvSpPr>
-          <p:cNvPr id="33" name="TextBox 32"/>
-          <p:cNvSpPr txBox="1"/>
-          <p:nvPr/>
-        </p:nvSpPr>
-        <p:spPr>
-          <a:xfrm>
-            <a:off x="1633575" y="5010912"/>
-            <a:ext cx="8924544" cy="256032"/>
-          </a:xfrm>
-          <a:prstGeom prst="rect">
-            <a:avLst/>
-          </a:prstGeom>
-          <a:noFill/>
-        </p:spPr>
-        <p:txBody>
-          <a:bodyPr wrap="square">
-            <a:spAutoFit/>
-          </a:bodyPr>
-          <a:lstStyle/>
-          <a:p>
-            <a:pPr algn="ctr">
-              <a:lnSpc>
-                <a:spcPct val="115000"/>
-              </a:lnSpc>
-              <a:defRPr sz="1100" b="1">
-                <a:solidFill>
-                  <a:srgbClr val="1A1A1A"/>
-                </a:solidFill>
-                <a:latin typeface="Calibri"/>
-              </a:defRPr>
-            </a:pPr>
-            <a:r>
-              <a:t>PMWeb</a:t>
-            </a:r>
-          </a:p>
-        </p:txBody>
-      </p:sp>
-      <p:sp>
-        <p:nvSpPr>
-          <p:cNvPr id="34" name="TextBox 33"/>
-          <p:cNvSpPr txBox="1"/>
-          <p:nvPr/>
-        </p:nvSpPr>
-        <p:spPr>
-          <a:xfrm>
-            <a:off x="1633575" y="5266944"/>
-            <a:ext cx="8924544" cy="128016"/>
-          </a:xfrm>
-          <a:prstGeom prst="rect">
-            <a:avLst/>
-          </a:prstGeom>
-          <a:noFill/>
-        </p:spPr>
-        <p:txBody>
-          <a:bodyPr wrap="square">
-            <a:spAutoFit/>
-          </a:bodyPr>
-          <a:lstStyle/>
-          <a:p>
-            <a:pPr algn="ctr">
-              <a:lnSpc>
-                <a:spcPct val="115000"/>
-              </a:lnSpc>
-              <a:defRPr sz="1100" b="0">
-                <a:solidFill>
-                  <a:srgbClr val="6B6B6B"/>
-                </a:solidFill>
-                <a:latin typeface="Calibri"/>
-              </a:defRPr>
-            </a:pPr>
-            <a:r>
-              <a:t>System of record — contracts, tenders, projects</a:t>
-            </a:r>
-          </a:p>
-        </p:txBody>
-      </p:sp>
-      <p:sp>
-        <p:nvSpPr>
-          <p:cNvPr id="35" name="Rounded Rectangle 34"/>
-          <p:cNvSpPr/>
-          <p:nvPr/>
-        </p:nvSpPr>
-        <p:spPr>
-          <a:xfrm>
-            <a:off x="1523847" y="5504688"/>
-            <a:ext cx="9144000" cy="384048"/>
-          </a:xfrm>
-          <a:prstGeom prst="roundRect">
-            <a:avLst/>
-          </a:prstGeom>
-          <a:solidFill>
-            <a:srgbClr val="FDF2F4"/>
-          </a:solidFill>
-          <a:ln w="9525">
-            <a:solidFill>
-              <a:srgbClr val="E31837"/>
-            </a:solidFill>
-          </a:ln>
-        </p:spPr>
-        <p:style>
-          <a:lnRef idx="1">
-            <a:schemeClr val="accent1"/>
-          </a:lnRef>
-          <a:fillRef idx="3">
-            <a:schemeClr val="accent1"/>
-          </a:fillRef>
-          <a:effectRef idx="2">
-            <a:schemeClr val="accent1"/>
-          </a:effectRef>
-          <a:fontRef idx="minor">
-            <a:schemeClr val="lt1"/>
-          </a:fontRef>
-        </p:style>
-        <p:txBody>
-          <a:bodyPr rtlCol="0" anchor="ctr"/>
-          <a:lstStyle/>
-          <a:p>
-            <a:pPr algn="ctr"/>
-          </a:p>
-        </p:txBody>
-      </p:sp>
-      <p:sp>
-        <p:nvSpPr>
-          <p:cNvPr id="36" name="TextBox 35"/>
-          <p:cNvSpPr txBox="1"/>
-          <p:nvPr/>
-        </p:nvSpPr>
-        <p:spPr>
-          <a:xfrm>
-            <a:off x="1661007" y="5577840"/>
-            <a:ext cx="8869680" cy="256032"/>
+          <p:cNvPr id="35" name="TextBox 34"/>
+          <p:cNvSpPr txBox="1"/>
+          <p:nvPr/>
+        </p:nvSpPr>
+        <p:spPr>
+          <a:xfrm>
+            <a:off x="1816455" y="5175504"/>
+            <a:ext cx="8558784" cy="256032"/>
           </a:xfrm>
           <a:prstGeom prst="rect">
             <a:avLst/>
@@ -11516,40 +11450,16 @@
           </a:p>
         </p:txBody>
       </p:sp>
-      <p:pic>
-        <p:nvPicPr>
-          <p:cNvPr id="11" name="Picture 10" descr="rag_pipeline.png"/>
-          <p:cNvPicPr>
-            <a:picLocks noChangeAspect="1"/>
-          </p:cNvPicPr>
-          <p:nvPr/>
-        </p:nvPicPr>
-        <p:blipFill>
-          <a:blip r:embed="rId3"/>
-          <a:stretch>
-            <a:fillRect/>
-          </a:stretch>
-        </p:blipFill>
-        <p:spPr>
-          <a:xfrm>
-            <a:off x="548640" y="1572768"/>
-            <a:ext cx="5274129" cy="868680"/>
-          </a:xfrm>
-          <a:prstGeom prst="rect">
-            <a:avLst/>
-          </a:prstGeom>
-        </p:spPr>
-      </p:pic>
-      <p:sp>
-        <p:nvSpPr>
-          <p:cNvPr id="12" name="Rounded Rectangle 11"/>
+      <p:sp>
+        <p:nvSpPr>
+          <p:cNvPr id="11" name="Rounded Rectangle 10"/>
           <p:cNvSpPr/>
           <p:nvPr/>
         </p:nvSpPr>
         <p:spPr>
           <a:xfrm>
-            <a:off x="548640" y="2532888"/>
-            <a:ext cx="5349240" cy="932688"/>
+            <a:off x="1307592" y="1618488"/>
+            <a:ext cx="1207008" cy="658368"/>
           </a:xfrm>
           <a:prstGeom prst="roundRect">
             <a:avLst/>
@@ -11587,16 +11497,55 @@
       </p:sp>
       <p:sp>
         <p:nvSpPr>
-          <p:cNvPr id="13" name="Rectangle 12"/>
+          <p:cNvPr id="12" name="TextBox 11"/>
+          <p:cNvSpPr txBox="1"/>
+          <p:nvPr/>
+        </p:nvSpPr>
+        <p:spPr>
+          <a:xfrm>
+            <a:off x="1344168" y="1819656"/>
+            <a:ext cx="1133856" cy="320040"/>
+          </a:xfrm>
+          <a:prstGeom prst="rect">
+            <a:avLst/>
+          </a:prstGeom>
+          <a:noFill/>
+        </p:spPr>
+        <p:txBody>
+          <a:bodyPr wrap="square">
+            <a:spAutoFit/>
+          </a:bodyPr>
+          <a:lstStyle/>
+          <a:p>
+            <a:pPr algn="ctr">
+              <a:lnSpc>
+                <a:spcPct val="115000"/>
+              </a:lnSpc>
+              <a:defRPr sz="1100" b="1">
+                <a:solidFill>
+                  <a:srgbClr val="1A1A1A"/>
+                </a:solidFill>
+                <a:latin typeface="Calibri"/>
+              </a:defRPr>
+            </a:pPr>
+            <a:r>
+              <a:t>PMWeb Docs</a:t>
+            </a:r>
+          </a:p>
+        </p:txBody>
+      </p:sp>
+      <p:sp>
+        <p:nvSpPr>
+          <p:cNvPr id="13" name="Right Arrow 12"/>
           <p:cNvSpPr/>
           <p:nvPr/>
         </p:nvSpPr>
         <p:spPr>
           <a:xfrm>
-            <a:off x="548640" y="2532888"/>
-            <a:ext cx="64008" cy="932688"/>
-          </a:xfrm>
-          <a:prstGeom prst="rect">
+            <a:off x="2514600" y="1874520"/>
+            <a:ext cx="201168" cy="128016"/>
+          </a:xfrm>
+          <a:prstGeom prst="rightArrow">
             <a:avLst/>
           </a:prstGeom>
           <a:solidFill>
@@ -11630,95 +11579,14 @@
       </p:sp>
       <p:sp>
         <p:nvSpPr>
-          <p:cNvPr id="14" name="TextBox 13"/>
-          <p:cNvSpPr txBox="1"/>
-          <p:nvPr/>
-        </p:nvSpPr>
-        <p:spPr>
-          <a:xfrm>
-            <a:off x="731520" y="2660904"/>
-            <a:ext cx="5029200" cy="329184"/>
-          </a:xfrm>
-          <a:prstGeom prst="rect">
-            <a:avLst/>
-          </a:prstGeom>
-          <a:noFill/>
-        </p:spPr>
-        <p:txBody>
-          <a:bodyPr wrap="square">
-            <a:spAutoFit/>
-          </a:bodyPr>
-          <a:lstStyle/>
-          <a:p>
-            <a:pPr algn="l">
-              <a:lnSpc>
-                <a:spcPct val="115000"/>
-              </a:lnSpc>
-              <a:defRPr sz="1100" b="1">
-                <a:solidFill>
-                  <a:srgbClr val="1A1A1A"/>
-                </a:solidFill>
-                <a:latin typeface="Calibri"/>
-              </a:defRPr>
-            </a:pPr>
-            <a:r>
-              <a:t>Document Ingestion</a:t>
-            </a:r>
-          </a:p>
-        </p:txBody>
-      </p:sp>
-      <p:sp>
-        <p:nvSpPr>
-          <p:cNvPr id="15" name="TextBox 14"/>
-          <p:cNvSpPr txBox="1"/>
-          <p:nvPr/>
-        </p:nvSpPr>
-        <p:spPr>
-          <a:xfrm>
-            <a:off x="731520" y="3008376"/>
-            <a:ext cx="5029200" cy="402336"/>
-          </a:xfrm>
-          <a:prstGeom prst="rect">
-            <a:avLst/>
-          </a:prstGeom>
-          <a:noFill/>
-        </p:spPr>
-        <p:txBody>
-          <a:bodyPr wrap="square">
-            <a:spAutoFit/>
-          </a:bodyPr>
-          <a:lstStyle/>
-          <a:p>
-            <a:pPr>
-              <a:lnSpc>
-                <a:spcPct val="120000"/>
-              </a:lnSpc>
-              <a:spcAft>
-                <a:spcPts val="600"/>
-              </a:spcAft>
-              <a:defRPr sz="1100">
-                <a:solidFill>
-                  <a:srgbClr val="6B6B6B"/>
-                </a:solidFill>
-                <a:latin typeface="Calibri"/>
-              </a:defRPr>
-            </a:pPr>
-            <a:r>
-              <a:t>• PDF, Word, PMWeb exports — OCR and classification</a:t>
-            </a:r>
-          </a:p>
-        </p:txBody>
-      </p:sp>
-      <p:sp>
-        <p:nvSpPr>
-          <p:cNvPr id="16" name="Rounded Rectangle 15"/>
+          <p:cNvPr id="14" name="Rounded Rectangle 13"/>
           <p:cNvSpPr/>
           <p:nvPr/>
         </p:nvSpPr>
         <p:spPr>
           <a:xfrm>
-            <a:off x="6172200" y="2532888"/>
-            <a:ext cx="5349240" cy="932688"/>
+            <a:off x="2697480" y="1618488"/>
+            <a:ext cx="1207008" cy="658368"/>
           </a:xfrm>
           <a:prstGeom prst="roundRect">
             <a:avLst/>
@@ -11756,16 +11624,55 @@
       </p:sp>
       <p:sp>
         <p:nvSpPr>
-          <p:cNvPr id="17" name="Rectangle 16"/>
+          <p:cNvPr id="15" name="TextBox 14"/>
+          <p:cNvSpPr txBox="1"/>
+          <p:nvPr/>
+        </p:nvSpPr>
+        <p:spPr>
+          <a:xfrm>
+            <a:off x="2734056" y="1819656"/>
+            <a:ext cx="1133856" cy="320040"/>
+          </a:xfrm>
+          <a:prstGeom prst="rect">
+            <a:avLst/>
+          </a:prstGeom>
+          <a:noFill/>
+        </p:spPr>
+        <p:txBody>
+          <a:bodyPr wrap="square">
+            <a:spAutoFit/>
+          </a:bodyPr>
+          <a:lstStyle/>
+          <a:p>
+            <a:pPr algn="ctr">
+              <a:lnSpc>
+                <a:spcPct val="115000"/>
+              </a:lnSpc>
+              <a:defRPr sz="1100" b="1">
+                <a:solidFill>
+                  <a:srgbClr val="1A1A1A"/>
+                </a:solidFill>
+                <a:latin typeface="Calibri"/>
+              </a:defRPr>
+            </a:pPr>
+            <a:r>
+              <a:t>Ingestion</a:t>
+            </a:r>
+          </a:p>
+        </p:txBody>
+      </p:sp>
+      <p:sp>
+        <p:nvSpPr>
+          <p:cNvPr id="16" name="Right Arrow 15"/>
           <p:cNvSpPr/>
           <p:nvPr/>
         </p:nvSpPr>
         <p:spPr>
           <a:xfrm>
-            <a:off x="6172200" y="2532888"/>
-            <a:ext cx="64008" cy="932688"/>
-          </a:xfrm>
-          <a:prstGeom prst="rect">
+            <a:off x="3904488" y="1874520"/>
+            <a:ext cx="201168" cy="128016"/>
+          </a:xfrm>
+          <a:prstGeom prst="rightArrow">
             <a:avLst/>
           </a:prstGeom>
           <a:solidFill>
@@ -11799,95 +11706,14 @@
       </p:sp>
       <p:sp>
         <p:nvSpPr>
-          <p:cNvPr id="18" name="TextBox 17"/>
-          <p:cNvSpPr txBox="1"/>
-          <p:nvPr/>
-        </p:nvSpPr>
-        <p:spPr>
-          <a:xfrm>
-            <a:off x="6355080" y="2660904"/>
-            <a:ext cx="5029200" cy="329184"/>
-          </a:xfrm>
-          <a:prstGeom prst="rect">
-            <a:avLst/>
-          </a:prstGeom>
-          <a:noFill/>
-        </p:spPr>
-        <p:txBody>
-          <a:bodyPr wrap="square">
-            <a:spAutoFit/>
-          </a:bodyPr>
-          <a:lstStyle/>
-          <a:p>
-            <a:pPr algn="l">
-              <a:lnSpc>
-                <a:spcPct val="115000"/>
-              </a:lnSpc>
-              <a:defRPr sz="1100" b="1">
-                <a:solidFill>
-                  <a:srgbClr val="1A1A1A"/>
-                </a:solidFill>
-                <a:latin typeface="Calibri"/>
-              </a:defRPr>
-            </a:pPr>
-            <a:r>
-              <a:t>Orchestration Engine</a:t>
-            </a:r>
-          </a:p>
-        </p:txBody>
-      </p:sp>
-      <p:sp>
-        <p:nvSpPr>
-          <p:cNvPr id="19" name="TextBox 18"/>
-          <p:cNvSpPr txBox="1"/>
-          <p:nvPr/>
-        </p:nvSpPr>
-        <p:spPr>
-          <a:xfrm>
-            <a:off x="6355080" y="3008376"/>
-            <a:ext cx="5029200" cy="402336"/>
-          </a:xfrm>
-          <a:prstGeom prst="rect">
-            <a:avLst/>
-          </a:prstGeom>
-          <a:noFill/>
-        </p:spPr>
-        <p:txBody>
-          <a:bodyPr wrap="square">
-            <a:spAutoFit/>
-          </a:bodyPr>
-          <a:lstStyle/>
-          <a:p>
-            <a:pPr>
-              <a:lnSpc>
-                <a:spcPct val="120000"/>
-              </a:lnSpc>
-              <a:spcAft>
-                <a:spcPts val="600"/>
-              </a:spcAft>
-              <a:defRPr sz="1100">
-                <a:solidFill>
-                  <a:srgbClr val="6B6B6B"/>
-                </a:solidFill>
-                <a:latin typeface="Calibri"/>
-              </a:defRPr>
-            </a:pPr>
-            <a:r>
-              <a:t>• Policy routing, fallbacks, evaluation hooks</a:t>
-            </a:r>
-          </a:p>
-        </p:txBody>
-      </p:sp>
-      <p:sp>
-        <p:nvSpPr>
-          <p:cNvPr id="20" name="Rounded Rectangle 19"/>
+          <p:cNvPr id="17" name="Rounded Rectangle 16"/>
           <p:cNvSpPr/>
           <p:nvPr/>
         </p:nvSpPr>
         <p:spPr>
           <a:xfrm>
-            <a:off x="548640" y="3648456"/>
-            <a:ext cx="5349240" cy="932688"/>
+            <a:off x="4087368" y="1618488"/>
+            <a:ext cx="1207008" cy="658368"/>
           </a:xfrm>
           <a:prstGeom prst="roundRect">
             <a:avLst/>
@@ -11925,16 +11751,55 @@
       </p:sp>
       <p:sp>
         <p:nvSpPr>
-          <p:cNvPr id="21" name="Rectangle 20"/>
+          <p:cNvPr id="18" name="TextBox 17"/>
+          <p:cNvSpPr txBox="1"/>
+          <p:nvPr/>
+        </p:nvSpPr>
+        <p:spPr>
+          <a:xfrm>
+            <a:off x="4123944" y="1819656"/>
+            <a:ext cx="1133856" cy="320040"/>
+          </a:xfrm>
+          <a:prstGeom prst="rect">
+            <a:avLst/>
+          </a:prstGeom>
+          <a:noFill/>
+        </p:spPr>
+        <p:txBody>
+          <a:bodyPr wrap="square">
+            <a:spAutoFit/>
+          </a:bodyPr>
+          <a:lstStyle/>
+          <a:p>
+            <a:pPr algn="ctr">
+              <a:lnSpc>
+                <a:spcPct val="115000"/>
+              </a:lnSpc>
+              <a:defRPr sz="1100" b="1">
+                <a:solidFill>
+                  <a:srgbClr val="1A1A1A"/>
+                </a:solidFill>
+                <a:latin typeface="Calibri"/>
+              </a:defRPr>
+            </a:pPr>
+            <a:r>
+              <a:t>Embedding</a:t>
+            </a:r>
+          </a:p>
+        </p:txBody>
+      </p:sp>
+      <p:sp>
+        <p:nvSpPr>
+          <p:cNvPr id="19" name="Right Arrow 18"/>
           <p:cNvSpPr/>
           <p:nvPr/>
         </p:nvSpPr>
         <p:spPr>
           <a:xfrm>
-            <a:off x="548640" y="3648456"/>
-            <a:ext cx="64008" cy="932688"/>
-          </a:xfrm>
-          <a:prstGeom prst="rect">
+            <a:off x="5294376" y="1874520"/>
+            <a:ext cx="201168" cy="128016"/>
+          </a:xfrm>
+          <a:prstGeom prst="rightArrow">
             <a:avLst/>
           </a:prstGeom>
           <a:solidFill>
@@ -11968,95 +11833,14 @@
       </p:sp>
       <p:sp>
         <p:nvSpPr>
-          <p:cNvPr id="22" name="TextBox 21"/>
-          <p:cNvSpPr txBox="1"/>
-          <p:nvPr/>
-        </p:nvSpPr>
-        <p:spPr>
-          <a:xfrm>
-            <a:off x="731520" y="3776472"/>
-            <a:ext cx="5029200" cy="329184"/>
-          </a:xfrm>
-          <a:prstGeom prst="rect">
-            <a:avLst/>
-          </a:prstGeom>
-          <a:noFill/>
-        </p:spPr>
-        <p:txBody>
-          <a:bodyPr wrap="square">
-            <a:spAutoFit/>
-          </a:bodyPr>
-          <a:lstStyle/>
-          <a:p>
-            <a:pPr algn="l">
-              <a:lnSpc>
-                <a:spcPct val="115000"/>
-              </a:lnSpc>
-              <a:defRPr sz="1100" b="1">
-                <a:solidFill>
-                  <a:srgbClr val="1A1A1A"/>
-                </a:solidFill>
-                <a:latin typeface="Calibri"/>
-              </a:defRPr>
-            </a:pPr>
-            <a:r>
-              <a:t>AI Governance Layer</a:t>
-            </a:r>
-          </a:p>
-        </p:txBody>
-      </p:sp>
-      <p:sp>
-        <p:nvSpPr>
-          <p:cNvPr id="23" name="TextBox 22"/>
-          <p:cNvSpPr txBox="1"/>
-          <p:nvPr/>
-        </p:nvSpPr>
-        <p:spPr>
-          <a:xfrm>
-            <a:off x="731520" y="4123944"/>
-            <a:ext cx="5029200" cy="402336"/>
-          </a:xfrm>
-          <a:prstGeom prst="rect">
-            <a:avLst/>
-          </a:prstGeom>
-          <a:noFill/>
-        </p:spPr>
-        <p:txBody>
-          <a:bodyPr wrap="square">
-            <a:spAutoFit/>
-          </a:bodyPr>
-          <a:lstStyle/>
-          <a:p>
-            <a:pPr>
-              <a:lnSpc>
-                <a:spcPct val="120000"/>
-              </a:lnSpc>
-              <a:spcAft>
-                <a:spcPts val="600"/>
-              </a:spcAft>
-              <a:defRPr sz="1100">
-                <a:solidFill>
-                  <a:srgbClr val="6B6B6B"/>
-                </a:solidFill>
-                <a:latin typeface="Calibri"/>
-              </a:defRPr>
-            </a:pPr>
-            <a:r>
-              <a:t>• PII redaction, output validation, kill switch</a:t>
-            </a:r>
-          </a:p>
-        </p:txBody>
-      </p:sp>
-      <p:sp>
-        <p:nvSpPr>
-          <p:cNvPr id="24" name="Rounded Rectangle 23"/>
+          <p:cNvPr id="20" name="Rounded Rectangle 19"/>
           <p:cNvSpPr/>
           <p:nvPr/>
         </p:nvSpPr>
         <p:spPr>
           <a:xfrm>
-            <a:off x="6172200" y="3648456"/>
-            <a:ext cx="5349240" cy="932688"/>
+            <a:off x="5477256" y="1618488"/>
+            <a:ext cx="1207008" cy="658368"/>
           </a:xfrm>
           <a:prstGeom prst="roundRect">
             <a:avLst/>
@@ -12094,16 +11878,55 @@
       </p:sp>
       <p:sp>
         <p:nvSpPr>
-          <p:cNvPr id="25" name="Rectangle 24"/>
+          <p:cNvPr id="21" name="TextBox 20"/>
+          <p:cNvSpPr txBox="1"/>
+          <p:nvPr/>
+        </p:nvSpPr>
+        <p:spPr>
+          <a:xfrm>
+            <a:off x="5513832" y="1819656"/>
+            <a:ext cx="1133856" cy="320040"/>
+          </a:xfrm>
+          <a:prstGeom prst="rect">
+            <a:avLst/>
+          </a:prstGeom>
+          <a:noFill/>
+        </p:spPr>
+        <p:txBody>
+          <a:bodyPr wrap="square">
+            <a:spAutoFit/>
+          </a:bodyPr>
+          <a:lstStyle/>
+          <a:p>
+            <a:pPr algn="ctr">
+              <a:lnSpc>
+                <a:spcPct val="115000"/>
+              </a:lnSpc>
+              <a:defRPr sz="1100" b="1">
+                <a:solidFill>
+                  <a:srgbClr val="1A1A1A"/>
+                </a:solidFill>
+                <a:latin typeface="Calibri"/>
+              </a:defRPr>
+            </a:pPr>
+            <a:r>
+              <a:t>Vector DB</a:t>
+            </a:r>
+          </a:p>
+        </p:txBody>
+      </p:sp>
+      <p:sp>
+        <p:nvSpPr>
+          <p:cNvPr id="22" name="Right Arrow 21"/>
           <p:cNvSpPr/>
           <p:nvPr/>
         </p:nvSpPr>
         <p:spPr>
           <a:xfrm>
-            <a:off x="6172200" y="3648456"/>
-            <a:ext cx="64008" cy="932688"/>
-          </a:xfrm>
-          <a:prstGeom prst="rect">
+            <a:off x="6684264" y="1874520"/>
+            <a:ext cx="201168" cy="128016"/>
+          </a:xfrm>
+          <a:prstGeom prst="rightArrow">
             <a:avLst/>
           </a:prstGeom>
           <a:solidFill>
@@ -12137,14 +11960,440 @@
       </p:sp>
       <p:sp>
         <p:nvSpPr>
-          <p:cNvPr id="26" name="TextBox 25"/>
-          <p:cNvSpPr txBox="1"/>
-          <p:nvPr/>
-        </p:nvSpPr>
-        <p:spPr>
-          <a:xfrm>
-            <a:off x="6355080" y="3776472"/>
-            <a:ext cx="5029200" cy="329184"/>
+          <p:cNvPr id="23" name="Rounded Rectangle 22"/>
+          <p:cNvSpPr/>
+          <p:nvPr/>
+        </p:nvSpPr>
+        <p:spPr>
+          <a:xfrm>
+            <a:off x="6867144" y="1618488"/>
+            <a:ext cx="1207008" cy="658368"/>
+          </a:xfrm>
+          <a:prstGeom prst="roundRect">
+            <a:avLst/>
+          </a:prstGeom>
+          <a:solidFill>
+            <a:srgbClr val="FFFFFF"/>
+          </a:solidFill>
+          <a:ln w="9525">
+            <a:solidFill>
+              <a:srgbClr val="DDDDDD"/>
+            </a:solidFill>
+          </a:ln>
+        </p:spPr>
+        <p:style>
+          <a:lnRef idx="1">
+            <a:schemeClr val="accent1"/>
+          </a:lnRef>
+          <a:fillRef idx="3">
+            <a:schemeClr val="accent1"/>
+          </a:fillRef>
+          <a:effectRef idx="2">
+            <a:schemeClr val="accent1"/>
+          </a:effectRef>
+          <a:fontRef idx="minor">
+            <a:schemeClr val="lt1"/>
+          </a:fontRef>
+        </p:style>
+        <p:txBody>
+          <a:bodyPr rtlCol="0" anchor="ctr"/>
+          <a:lstStyle/>
+          <a:p>
+            <a:pPr algn="ctr"/>
+          </a:p>
+        </p:txBody>
+      </p:sp>
+      <p:sp>
+        <p:nvSpPr>
+          <p:cNvPr id="24" name="TextBox 23"/>
+          <p:cNvSpPr txBox="1"/>
+          <p:nvPr/>
+        </p:nvSpPr>
+        <p:spPr>
+          <a:xfrm>
+            <a:off x="6903720" y="1819656"/>
+            <a:ext cx="1133856" cy="320040"/>
+          </a:xfrm>
+          <a:prstGeom prst="rect">
+            <a:avLst/>
+          </a:prstGeom>
+          <a:noFill/>
+        </p:spPr>
+        <p:txBody>
+          <a:bodyPr wrap="square">
+            <a:spAutoFit/>
+          </a:bodyPr>
+          <a:lstStyle/>
+          <a:p>
+            <a:pPr algn="ctr">
+              <a:lnSpc>
+                <a:spcPct val="115000"/>
+              </a:lnSpc>
+              <a:defRPr sz="1100" b="1">
+                <a:solidFill>
+                  <a:srgbClr val="1A1A1A"/>
+                </a:solidFill>
+                <a:latin typeface="Calibri"/>
+              </a:defRPr>
+            </a:pPr>
+            <a:r>
+              <a:t>RAG</a:t>
+            </a:r>
+          </a:p>
+        </p:txBody>
+      </p:sp>
+      <p:sp>
+        <p:nvSpPr>
+          <p:cNvPr id="25" name="Right Arrow 24"/>
+          <p:cNvSpPr/>
+          <p:nvPr/>
+        </p:nvSpPr>
+        <p:spPr>
+          <a:xfrm>
+            <a:off x="8074152" y="1874520"/>
+            <a:ext cx="201168" cy="128016"/>
+          </a:xfrm>
+          <a:prstGeom prst="rightArrow">
+            <a:avLst/>
+          </a:prstGeom>
+          <a:solidFill>
+            <a:srgbClr val="E31837"/>
+          </a:solidFill>
+          <a:ln>
+            <a:noFill/>
+          </a:ln>
+        </p:spPr>
+        <p:style>
+          <a:lnRef idx="1">
+            <a:schemeClr val="accent1"/>
+          </a:lnRef>
+          <a:fillRef idx="3">
+            <a:schemeClr val="accent1"/>
+          </a:fillRef>
+          <a:effectRef idx="2">
+            <a:schemeClr val="accent1"/>
+          </a:effectRef>
+          <a:fontRef idx="minor">
+            <a:schemeClr val="lt1"/>
+          </a:fontRef>
+        </p:style>
+        <p:txBody>
+          <a:bodyPr rtlCol="0" anchor="ctr"/>
+          <a:lstStyle/>
+          <a:p>
+            <a:pPr algn="ctr"/>
+          </a:p>
+        </p:txBody>
+      </p:sp>
+      <p:sp>
+        <p:nvSpPr>
+          <p:cNvPr id="26" name="Rounded Rectangle 25"/>
+          <p:cNvSpPr/>
+          <p:nvPr/>
+        </p:nvSpPr>
+        <p:spPr>
+          <a:xfrm>
+            <a:off x="8257032" y="1618488"/>
+            <a:ext cx="1207008" cy="658368"/>
+          </a:xfrm>
+          <a:prstGeom prst="roundRect">
+            <a:avLst/>
+          </a:prstGeom>
+          <a:solidFill>
+            <a:srgbClr val="FDF2F4"/>
+          </a:solidFill>
+          <a:ln w="9525">
+            <a:solidFill>
+              <a:srgbClr val="E31837"/>
+            </a:solidFill>
+          </a:ln>
+        </p:spPr>
+        <p:style>
+          <a:lnRef idx="1">
+            <a:schemeClr val="accent1"/>
+          </a:lnRef>
+          <a:fillRef idx="3">
+            <a:schemeClr val="accent1"/>
+          </a:fillRef>
+          <a:effectRef idx="2">
+            <a:schemeClr val="accent1"/>
+          </a:effectRef>
+          <a:fontRef idx="minor">
+            <a:schemeClr val="lt1"/>
+          </a:fontRef>
+        </p:style>
+        <p:txBody>
+          <a:bodyPr rtlCol="0" anchor="ctr"/>
+          <a:lstStyle/>
+          <a:p>
+            <a:pPr algn="ctr"/>
+          </a:p>
+        </p:txBody>
+      </p:sp>
+      <p:sp>
+        <p:nvSpPr>
+          <p:cNvPr id="27" name="TextBox 26"/>
+          <p:cNvSpPr txBox="1"/>
+          <p:nvPr/>
+        </p:nvSpPr>
+        <p:spPr>
+          <a:xfrm>
+            <a:off x="8293608" y="1819656"/>
+            <a:ext cx="1133856" cy="320040"/>
+          </a:xfrm>
+          <a:prstGeom prst="rect">
+            <a:avLst/>
+          </a:prstGeom>
+          <a:noFill/>
+        </p:spPr>
+        <p:txBody>
+          <a:bodyPr wrap="square">
+            <a:spAutoFit/>
+          </a:bodyPr>
+          <a:lstStyle/>
+          <a:p>
+            <a:pPr algn="ctr">
+              <a:lnSpc>
+                <a:spcPct val="115000"/>
+              </a:lnSpc>
+              <a:defRPr sz="1100" b="1">
+                <a:solidFill>
+                  <a:srgbClr val="B01228"/>
+                </a:solidFill>
+                <a:latin typeface="Calibri"/>
+              </a:defRPr>
+            </a:pPr>
+            <a:r>
+              <a:t>Claude</a:t>
+            </a:r>
+          </a:p>
+        </p:txBody>
+      </p:sp>
+      <p:sp>
+        <p:nvSpPr>
+          <p:cNvPr id="28" name="Right Arrow 27"/>
+          <p:cNvSpPr/>
+          <p:nvPr/>
+        </p:nvSpPr>
+        <p:spPr>
+          <a:xfrm>
+            <a:off x="9464040" y="1874520"/>
+            <a:ext cx="201168" cy="128016"/>
+          </a:xfrm>
+          <a:prstGeom prst="rightArrow">
+            <a:avLst/>
+          </a:prstGeom>
+          <a:solidFill>
+            <a:srgbClr val="E31837"/>
+          </a:solidFill>
+          <a:ln>
+            <a:noFill/>
+          </a:ln>
+        </p:spPr>
+        <p:style>
+          <a:lnRef idx="1">
+            <a:schemeClr val="accent1"/>
+          </a:lnRef>
+          <a:fillRef idx="3">
+            <a:schemeClr val="accent1"/>
+          </a:fillRef>
+          <a:effectRef idx="2">
+            <a:schemeClr val="accent1"/>
+          </a:effectRef>
+          <a:fontRef idx="minor">
+            <a:schemeClr val="lt1"/>
+          </a:fontRef>
+        </p:style>
+        <p:txBody>
+          <a:bodyPr rtlCol="0" anchor="ctr"/>
+          <a:lstStyle/>
+          <a:p>
+            <a:pPr algn="ctr"/>
+          </a:p>
+        </p:txBody>
+      </p:sp>
+      <p:sp>
+        <p:nvSpPr>
+          <p:cNvPr id="29" name="Rounded Rectangle 28"/>
+          <p:cNvSpPr/>
+          <p:nvPr/>
+        </p:nvSpPr>
+        <p:spPr>
+          <a:xfrm>
+            <a:off x="9646920" y="1618488"/>
+            <a:ext cx="1207008" cy="658368"/>
+          </a:xfrm>
+          <a:prstGeom prst="roundRect">
+            <a:avLst/>
+          </a:prstGeom>
+          <a:solidFill>
+            <a:srgbClr val="FFFFFF"/>
+          </a:solidFill>
+          <a:ln w="9525">
+            <a:solidFill>
+              <a:srgbClr val="DDDDDD"/>
+            </a:solidFill>
+          </a:ln>
+        </p:spPr>
+        <p:style>
+          <a:lnRef idx="1">
+            <a:schemeClr val="accent1"/>
+          </a:lnRef>
+          <a:fillRef idx="3">
+            <a:schemeClr val="accent1"/>
+          </a:fillRef>
+          <a:effectRef idx="2">
+            <a:schemeClr val="accent1"/>
+          </a:effectRef>
+          <a:fontRef idx="minor">
+            <a:schemeClr val="lt1"/>
+          </a:fontRef>
+        </p:style>
+        <p:txBody>
+          <a:bodyPr rtlCol="0" anchor="ctr"/>
+          <a:lstStyle/>
+          <a:p>
+            <a:pPr algn="ctr"/>
+          </a:p>
+        </p:txBody>
+      </p:sp>
+      <p:sp>
+        <p:nvSpPr>
+          <p:cNvPr id="30" name="TextBox 29"/>
+          <p:cNvSpPr txBox="1"/>
+          <p:nvPr/>
+        </p:nvSpPr>
+        <p:spPr>
+          <a:xfrm>
+            <a:off x="9683496" y="1819656"/>
+            <a:ext cx="1133856" cy="320040"/>
+          </a:xfrm>
+          <a:prstGeom prst="rect">
+            <a:avLst/>
+          </a:prstGeom>
+          <a:noFill/>
+        </p:spPr>
+        <p:txBody>
+          <a:bodyPr wrap="square">
+            <a:spAutoFit/>
+          </a:bodyPr>
+          <a:lstStyle/>
+          <a:p>
+            <a:pPr algn="ctr">
+              <a:lnSpc>
+                <a:spcPct val="115000"/>
+              </a:lnSpc>
+              <a:defRPr sz="1100" b="1">
+                <a:solidFill>
+                  <a:srgbClr val="1A1A1A"/>
+                </a:solidFill>
+                <a:latin typeface="Calibri"/>
+              </a:defRPr>
+            </a:pPr>
+            <a:r>
+              <a:t>Response</a:t>
+            </a:r>
+          </a:p>
+        </p:txBody>
+      </p:sp>
+      <p:sp>
+        <p:nvSpPr>
+          <p:cNvPr id="31" name="Rounded Rectangle 30"/>
+          <p:cNvSpPr/>
+          <p:nvPr/>
+        </p:nvSpPr>
+        <p:spPr>
+          <a:xfrm>
+            <a:off x="548640" y="2414016"/>
+            <a:ext cx="5372100" cy="987552"/>
+          </a:xfrm>
+          <a:prstGeom prst="roundRect">
+            <a:avLst/>
+          </a:prstGeom>
+          <a:solidFill>
+            <a:srgbClr val="FFFFFF"/>
+          </a:solidFill>
+          <a:ln w="9525">
+            <a:solidFill>
+              <a:srgbClr val="DDDDDD"/>
+            </a:solidFill>
+          </a:ln>
+        </p:spPr>
+        <p:style>
+          <a:lnRef idx="1">
+            <a:schemeClr val="accent1"/>
+          </a:lnRef>
+          <a:fillRef idx="3">
+            <a:schemeClr val="accent1"/>
+          </a:fillRef>
+          <a:effectRef idx="2">
+            <a:schemeClr val="accent1"/>
+          </a:effectRef>
+          <a:fontRef idx="minor">
+            <a:schemeClr val="lt1"/>
+          </a:fontRef>
+        </p:style>
+        <p:txBody>
+          <a:bodyPr rtlCol="0" anchor="ctr"/>
+          <a:lstStyle/>
+          <a:p>
+            <a:pPr algn="ctr"/>
+          </a:p>
+        </p:txBody>
+      </p:sp>
+      <p:sp>
+        <p:nvSpPr>
+          <p:cNvPr id="32" name="Rectangle 31"/>
+          <p:cNvSpPr/>
+          <p:nvPr/>
+        </p:nvSpPr>
+        <p:spPr>
+          <a:xfrm>
+            <a:off x="548640" y="2414016"/>
+            <a:ext cx="64008" cy="987552"/>
+          </a:xfrm>
+          <a:prstGeom prst="rect">
+            <a:avLst/>
+          </a:prstGeom>
+          <a:solidFill>
+            <a:srgbClr val="E31837"/>
+          </a:solidFill>
+          <a:ln>
+            <a:noFill/>
+          </a:ln>
+        </p:spPr>
+        <p:style>
+          <a:lnRef idx="1">
+            <a:schemeClr val="accent1"/>
+          </a:lnRef>
+          <a:fillRef idx="3">
+            <a:schemeClr val="accent1"/>
+          </a:fillRef>
+          <a:effectRef idx="2">
+            <a:schemeClr val="accent1"/>
+          </a:effectRef>
+          <a:fontRef idx="minor">
+            <a:schemeClr val="lt1"/>
+          </a:fontRef>
+        </p:style>
+        <p:txBody>
+          <a:bodyPr rtlCol="0" anchor="ctr"/>
+          <a:lstStyle/>
+          <a:p>
+            <a:pPr algn="ctr"/>
+          </a:p>
+        </p:txBody>
+      </p:sp>
+      <p:sp>
+        <p:nvSpPr>
+          <p:cNvPr id="33" name="TextBox 32"/>
+          <p:cNvSpPr txBox="1"/>
+          <p:nvPr/>
+        </p:nvSpPr>
+        <p:spPr>
+          <a:xfrm>
+            <a:off x="731520" y="2542032"/>
+            <a:ext cx="5052060" cy="329184"/>
           </a:xfrm>
           <a:prstGeom prst="rect">
             <a:avLst/>
@@ -12169,6 +12418,513 @@
               </a:defRPr>
             </a:pPr>
             <a:r>
+              <a:t>Document Ingestion</a:t>
+            </a:r>
+          </a:p>
+        </p:txBody>
+      </p:sp>
+      <p:sp>
+        <p:nvSpPr>
+          <p:cNvPr id="34" name="TextBox 33"/>
+          <p:cNvSpPr txBox="1"/>
+          <p:nvPr/>
+        </p:nvSpPr>
+        <p:spPr>
+          <a:xfrm>
+            <a:off x="731520" y="2889504"/>
+            <a:ext cx="5052060" cy="457200"/>
+          </a:xfrm>
+          <a:prstGeom prst="rect">
+            <a:avLst/>
+          </a:prstGeom>
+          <a:noFill/>
+        </p:spPr>
+        <p:txBody>
+          <a:bodyPr wrap="square">
+            <a:spAutoFit/>
+          </a:bodyPr>
+          <a:lstStyle/>
+          <a:p>
+            <a:pPr>
+              <a:lnSpc>
+                <a:spcPct val="120000"/>
+              </a:lnSpc>
+              <a:spcAft>
+                <a:spcPts val="600"/>
+              </a:spcAft>
+              <a:defRPr sz="1100">
+                <a:solidFill>
+                  <a:srgbClr val="6B6B6B"/>
+                </a:solidFill>
+                <a:latin typeface="Calibri"/>
+              </a:defRPr>
+            </a:pPr>
+            <a:r>
+              <a:t>• PDF, Word, PMWeb exports — OCR and classification</a:t>
+            </a:r>
+          </a:p>
+        </p:txBody>
+      </p:sp>
+      <p:sp>
+        <p:nvSpPr>
+          <p:cNvPr id="35" name="Rounded Rectangle 34"/>
+          <p:cNvSpPr/>
+          <p:nvPr/>
+        </p:nvSpPr>
+        <p:spPr>
+          <a:xfrm>
+            <a:off x="6240780" y="2414016"/>
+            <a:ext cx="5372100" cy="987552"/>
+          </a:xfrm>
+          <a:prstGeom prst="roundRect">
+            <a:avLst/>
+          </a:prstGeom>
+          <a:solidFill>
+            <a:srgbClr val="FFFFFF"/>
+          </a:solidFill>
+          <a:ln w="9525">
+            <a:solidFill>
+              <a:srgbClr val="DDDDDD"/>
+            </a:solidFill>
+          </a:ln>
+        </p:spPr>
+        <p:style>
+          <a:lnRef idx="1">
+            <a:schemeClr val="accent1"/>
+          </a:lnRef>
+          <a:fillRef idx="3">
+            <a:schemeClr val="accent1"/>
+          </a:fillRef>
+          <a:effectRef idx="2">
+            <a:schemeClr val="accent1"/>
+          </a:effectRef>
+          <a:fontRef idx="minor">
+            <a:schemeClr val="lt1"/>
+          </a:fontRef>
+        </p:style>
+        <p:txBody>
+          <a:bodyPr rtlCol="0" anchor="ctr"/>
+          <a:lstStyle/>
+          <a:p>
+            <a:pPr algn="ctr"/>
+          </a:p>
+        </p:txBody>
+      </p:sp>
+      <p:sp>
+        <p:nvSpPr>
+          <p:cNvPr id="36" name="Rectangle 35"/>
+          <p:cNvSpPr/>
+          <p:nvPr/>
+        </p:nvSpPr>
+        <p:spPr>
+          <a:xfrm>
+            <a:off x="6240780" y="2414016"/>
+            <a:ext cx="64008" cy="987552"/>
+          </a:xfrm>
+          <a:prstGeom prst="rect">
+            <a:avLst/>
+          </a:prstGeom>
+          <a:solidFill>
+            <a:srgbClr val="E31837"/>
+          </a:solidFill>
+          <a:ln>
+            <a:noFill/>
+          </a:ln>
+        </p:spPr>
+        <p:style>
+          <a:lnRef idx="1">
+            <a:schemeClr val="accent1"/>
+          </a:lnRef>
+          <a:fillRef idx="3">
+            <a:schemeClr val="accent1"/>
+          </a:fillRef>
+          <a:effectRef idx="2">
+            <a:schemeClr val="accent1"/>
+          </a:effectRef>
+          <a:fontRef idx="minor">
+            <a:schemeClr val="lt1"/>
+          </a:fontRef>
+        </p:style>
+        <p:txBody>
+          <a:bodyPr rtlCol="0" anchor="ctr"/>
+          <a:lstStyle/>
+          <a:p>
+            <a:pPr algn="ctr"/>
+          </a:p>
+        </p:txBody>
+      </p:sp>
+      <p:sp>
+        <p:nvSpPr>
+          <p:cNvPr id="37" name="TextBox 36"/>
+          <p:cNvSpPr txBox="1"/>
+          <p:nvPr/>
+        </p:nvSpPr>
+        <p:spPr>
+          <a:xfrm>
+            <a:off x="6423660" y="2542032"/>
+            <a:ext cx="5052060" cy="329184"/>
+          </a:xfrm>
+          <a:prstGeom prst="rect">
+            <a:avLst/>
+          </a:prstGeom>
+          <a:noFill/>
+        </p:spPr>
+        <p:txBody>
+          <a:bodyPr wrap="square">
+            <a:spAutoFit/>
+          </a:bodyPr>
+          <a:lstStyle/>
+          <a:p>
+            <a:pPr algn="l">
+              <a:lnSpc>
+                <a:spcPct val="115000"/>
+              </a:lnSpc>
+              <a:defRPr sz="1100" b="1">
+                <a:solidFill>
+                  <a:srgbClr val="1A1A1A"/>
+                </a:solidFill>
+                <a:latin typeface="Calibri"/>
+              </a:defRPr>
+            </a:pPr>
+            <a:r>
+              <a:t>Orchestration Engine</a:t>
+            </a:r>
+          </a:p>
+        </p:txBody>
+      </p:sp>
+      <p:sp>
+        <p:nvSpPr>
+          <p:cNvPr id="38" name="TextBox 37"/>
+          <p:cNvSpPr txBox="1"/>
+          <p:nvPr/>
+        </p:nvSpPr>
+        <p:spPr>
+          <a:xfrm>
+            <a:off x="6423660" y="2889504"/>
+            <a:ext cx="5052060" cy="457200"/>
+          </a:xfrm>
+          <a:prstGeom prst="rect">
+            <a:avLst/>
+          </a:prstGeom>
+          <a:noFill/>
+        </p:spPr>
+        <p:txBody>
+          <a:bodyPr wrap="square">
+            <a:spAutoFit/>
+          </a:bodyPr>
+          <a:lstStyle/>
+          <a:p>
+            <a:pPr>
+              <a:lnSpc>
+                <a:spcPct val="120000"/>
+              </a:lnSpc>
+              <a:spcAft>
+                <a:spcPts val="600"/>
+              </a:spcAft>
+              <a:defRPr sz="1100">
+                <a:solidFill>
+                  <a:srgbClr val="6B6B6B"/>
+                </a:solidFill>
+                <a:latin typeface="Calibri"/>
+              </a:defRPr>
+            </a:pPr>
+            <a:r>
+              <a:t>• Policy routing, fallbacks, evaluation hooks</a:t>
+            </a:r>
+          </a:p>
+        </p:txBody>
+      </p:sp>
+      <p:sp>
+        <p:nvSpPr>
+          <p:cNvPr id="39" name="Rounded Rectangle 38"/>
+          <p:cNvSpPr/>
+          <p:nvPr/>
+        </p:nvSpPr>
+        <p:spPr>
+          <a:xfrm>
+            <a:off x="548640" y="3657600"/>
+            <a:ext cx="5372100" cy="987552"/>
+          </a:xfrm>
+          <a:prstGeom prst="roundRect">
+            <a:avLst/>
+          </a:prstGeom>
+          <a:solidFill>
+            <a:srgbClr val="FFFFFF"/>
+          </a:solidFill>
+          <a:ln w="9525">
+            <a:solidFill>
+              <a:srgbClr val="DDDDDD"/>
+            </a:solidFill>
+          </a:ln>
+        </p:spPr>
+        <p:style>
+          <a:lnRef idx="1">
+            <a:schemeClr val="accent1"/>
+          </a:lnRef>
+          <a:fillRef idx="3">
+            <a:schemeClr val="accent1"/>
+          </a:fillRef>
+          <a:effectRef idx="2">
+            <a:schemeClr val="accent1"/>
+          </a:effectRef>
+          <a:fontRef idx="minor">
+            <a:schemeClr val="lt1"/>
+          </a:fontRef>
+        </p:style>
+        <p:txBody>
+          <a:bodyPr rtlCol="0" anchor="ctr"/>
+          <a:lstStyle/>
+          <a:p>
+            <a:pPr algn="ctr"/>
+          </a:p>
+        </p:txBody>
+      </p:sp>
+      <p:sp>
+        <p:nvSpPr>
+          <p:cNvPr id="40" name="Rectangle 39"/>
+          <p:cNvSpPr/>
+          <p:nvPr/>
+        </p:nvSpPr>
+        <p:spPr>
+          <a:xfrm>
+            <a:off x="548640" y="3657600"/>
+            <a:ext cx="64008" cy="987552"/>
+          </a:xfrm>
+          <a:prstGeom prst="rect">
+            <a:avLst/>
+          </a:prstGeom>
+          <a:solidFill>
+            <a:srgbClr val="E31837"/>
+          </a:solidFill>
+          <a:ln>
+            <a:noFill/>
+          </a:ln>
+        </p:spPr>
+        <p:style>
+          <a:lnRef idx="1">
+            <a:schemeClr val="accent1"/>
+          </a:lnRef>
+          <a:fillRef idx="3">
+            <a:schemeClr val="accent1"/>
+          </a:fillRef>
+          <a:effectRef idx="2">
+            <a:schemeClr val="accent1"/>
+          </a:effectRef>
+          <a:fontRef idx="minor">
+            <a:schemeClr val="lt1"/>
+          </a:fontRef>
+        </p:style>
+        <p:txBody>
+          <a:bodyPr rtlCol="0" anchor="ctr"/>
+          <a:lstStyle/>
+          <a:p>
+            <a:pPr algn="ctr"/>
+          </a:p>
+        </p:txBody>
+      </p:sp>
+      <p:sp>
+        <p:nvSpPr>
+          <p:cNvPr id="41" name="TextBox 40"/>
+          <p:cNvSpPr txBox="1"/>
+          <p:nvPr/>
+        </p:nvSpPr>
+        <p:spPr>
+          <a:xfrm>
+            <a:off x="731520" y="3785616"/>
+            <a:ext cx="5052060" cy="329184"/>
+          </a:xfrm>
+          <a:prstGeom prst="rect">
+            <a:avLst/>
+          </a:prstGeom>
+          <a:noFill/>
+        </p:spPr>
+        <p:txBody>
+          <a:bodyPr wrap="square">
+            <a:spAutoFit/>
+          </a:bodyPr>
+          <a:lstStyle/>
+          <a:p>
+            <a:pPr algn="l">
+              <a:lnSpc>
+                <a:spcPct val="115000"/>
+              </a:lnSpc>
+              <a:defRPr sz="1100" b="1">
+                <a:solidFill>
+                  <a:srgbClr val="1A1A1A"/>
+                </a:solidFill>
+                <a:latin typeface="Calibri"/>
+              </a:defRPr>
+            </a:pPr>
+            <a:r>
+              <a:t>AI Governance Layer</a:t>
+            </a:r>
+          </a:p>
+        </p:txBody>
+      </p:sp>
+      <p:sp>
+        <p:nvSpPr>
+          <p:cNvPr id="42" name="TextBox 41"/>
+          <p:cNvSpPr txBox="1"/>
+          <p:nvPr/>
+        </p:nvSpPr>
+        <p:spPr>
+          <a:xfrm>
+            <a:off x="731520" y="4133088"/>
+            <a:ext cx="5052060" cy="457200"/>
+          </a:xfrm>
+          <a:prstGeom prst="rect">
+            <a:avLst/>
+          </a:prstGeom>
+          <a:noFill/>
+        </p:spPr>
+        <p:txBody>
+          <a:bodyPr wrap="square">
+            <a:spAutoFit/>
+          </a:bodyPr>
+          <a:lstStyle/>
+          <a:p>
+            <a:pPr>
+              <a:lnSpc>
+                <a:spcPct val="120000"/>
+              </a:lnSpc>
+              <a:spcAft>
+                <a:spcPts val="600"/>
+              </a:spcAft>
+              <a:defRPr sz="1100">
+                <a:solidFill>
+                  <a:srgbClr val="6B6B6B"/>
+                </a:solidFill>
+                <a:latin typeface="Calibri"/>
+              </a:defRPr>
+            </a:pPr>
+            <a:r>
+              <a:t>• PII redaction, output validation, kill switch</a:t>
+            </a:r>
+          </a:p>
+        </p:txBody>
+      </p:sp>
+      <p:sp>
+        <p:nvSpPr>
+          <p:cNvPr id="43" name="Rounded Rectangle 42"/>
+          <p:cNvSpPr/>
+          <p:nvPr/>
+        </p:nvSpPr>
+        <p:spPr>
+          <a:xfrm>
+            <a:off x="6240780" y="3657600"/>
+            <a:ext cx="5372100" cy="987552"/>
+          </a:xfrm>
+          <a:prstGeom prst="roundRect">
+            <a:avLst/>
+          </a:prstGeom>
+          <a:solidFill>
+            <a:srgbClr val="FFFFFF"/>
+          </a:solidFill>
+          <a:ln w="9525">
+            <a:solidFill>
+              <a:srgbClr val="DDDDDD"/>
+            </a:solidFill>
+          </a:ln>
+        </p:spPr>
+        <p:style>
+          <a:lnRef idx="1">
+            <a:schemeClr val="accent1"/>
+          </a:lnRef>
+          <a:fillRef idx="3">
+            <a:schemeClr val="accent1"/>
+          </a:fillRef>
+          <a:effectRef idx="2">
+            <a:schemeClr val="accent1"/>
+          </a:effectRef>
+          <a:fontRef idx="minor">
+            <a:schemeClr val="lt1"/>
+          </a:fontRef>
+        </p:style>
+        <p:txBody>
+          <a:bodyPr rtlCol="0" anchor="ctr"/>
+          <a:lstStyle/>
+          <a:p>
+            <a:pPr algn="ctr"/>
+          </a:p>
+        </p:txBody>
+      </p:sp>
+      <p:sp>
+        <p:nvSpPr>
+          <p:cNvPr id="44" name="Rectangle 43"/>
+          <p:cNvSpPr/>
+          <p:nvPr/>
+        </p:nvSpPr>
+        <p:spPr>
+          <a:xfrm>
+            <a:off x="6240780" y="3657600"/>
+            <a:ext cx="64008" cy="987552"/>
+          </a:xfrm>
+          <a:prstGeom prst="rect">
+            <a:avLst/>
+          </a:prstGeom>
+          <a:solidFill>
+            <a:srgbClr val="E31837"/>
+          </a:solidFill>
+          <a:ln>
+            <a:noFill/>
+          </a:ln>
+        </p:spPr>
+        <p:style>
+          <a:lnRef idx="1">
+            <a:schemeClr val="accent1"/>
+          </a:lnRef>
+          <a:fillRef idx="3">
+            <a:schemeClr val="accent1"/>
+          </a:fillRef>
+          <a:effectRef idx="2">
+            <a:schemeClr val="accent1"/>
+          </a:effectRef>
+          <a:fontRef idx="minor">
+            <a:schemeClr val="lt1"/>
+          </a:fontRef>
+        </p:style>
+        <p:txBody>
+          <a:bodyPr rtlCol="0" anchor="ctr"/>
+          <a:lstStyle/>
+          <a:p>
+            <a:pPr algn="ctr"/>
+          </a:p>
+        </p:txBody>
+      </p:sp>
+      <p:sp>
+        <p:nvSpPr>
+          <p:cNvPr id="45" name="TextBox 44"/>
+          <p:cNvSpPr txBox="1"/>
+          <p:nvPr/>
+        </p:nvSpPr>
+        <p:spPr>
+          <a:xfrm>
+            <a:off x="6423660" y="3785616"/>
+            <a:ext cx="5052060" cy="329184"/>
+          </a:xfrm>
+          <a:prstGeom prst="rect">
+            <a:avLst/>
+          </a:prstGeom>
+          <a:noFill/>
+        </p:spPr>
+        <p:txBody>
+          <a:bodyPr wrap="square">
+            <a:spAutoFit/>
+          </a:bodyPr>
+          <a:lstStyle/>
+          <a:p>
+            <a:pPr algn="l">
+              <a:lnSpc>
+                <a:spcPct val="115000"/>
+              </a:lnSpc>
+              <a:defRPr sz="1100" b="1">
+                <a:solidFill>
+                  <a:srgbClr val="1A1A1A"/>
+                </a:solidFill>
+                <a:latin typeface="Calibri"/>
+              </a:defRPr>
+            </a:pPr>
+            <a:r>
               <a:t>PMWeb APIs</a:t>
             </a:r>
           </a:p>
@@ -12176,14 +12932,14 @@
       </p:sp>
       <p:sp>
         <p:nvSpPr>
-          <p:cNvPr id="27" name="TextBox 26"/>
-          <p:cNvSpPr txBox="1"/>
-          <p:nvPr/>
-        </p:nvSpPr>
-        <p:spPr>
-          <a:xfrm>
-            <a:off x="6355080" y="4123944"/>
-            <a:ext cx="5029200" cy="402336"/>
+          <p:cNvPr id="46" name="TextBox 45"/>
+          <p:cNvSpPr txBox="1"/>
+          <p:nvPr/>
+        </p:nvSpPr>
+        <p:spPr>
+          <a:xfrm>
+            <a:off x="6423660" y="4133088"/>
+            <a:ext cx="5052060" cy="457200"/>
           </a:xfrm>
           <a:prstGeom prst="rect">
             <a:avLst/>
@@ -25925,8 +26681,8 @@
         </p:nvSpPr>
         <p:spPr>
           <a:xfrm>
-            <a:off x="612648" y="2423160"/>
-            <a:ext cx="2112264" cy="256032"/>
+            <a:off x="630936" y="2414016"/>
+            <a:ext cx="2075688" cy="237744"/>
           </a:xfrm>
           <a:prstGeom prst="rect">
             <a:avLst/>
@@ -26009,8 +26765,8 @@
         </p:nvSpPr>
         <p:spPr>
           <a:xfrm>
-            <a:off x="9116568" y="2423160"/>
-            <a:ext cx="2112264" cy="256032"/>
+            <a:off x="9134856" y="2414016"/>
+            <a:ext cx="2075688" cy="237744"/>
           </a:xfrm>
           <a:prstGeom prst="rect">
             <a:avLst/>
@@ -26093,8 +26849,8 @@
         </p:nvSpPr>
         <p:spPr>
           <a:xfrm>
-            <a:off x="612648" y="4526280"/>
-            <a:ext cx="2112264" cy="256032"/>
+            <a:off x="630936" y="4517136"/>
+            <a:ext cx="2075688" cy="237744"/>
           </a:xfrm>
           <a:prstGeom prst="rect">
             <a:avLst/>
@@ -26177,8 +26933,8 @@
         </p:nvSpPr>
         <p:spPr>
           <a:xfrm>
-            <a:off x="9116568" y="4526280"/>
-            <a:ext cx="2112264" cy="256032"/>
+            <a:off x="9134856" y="4517136"/>
+            <a:ext cx="2075688" cy="237744"/>
           </a:xfrm>
           <a:prstGeom prst="rect">
             <a:avLst/>
@@ -26261,8 +27017,8 @@
         </p:nvSpPr>
         <p:spPr>
           <a:xfrm>
-            <a:off x="3035808" y="5166360"/>
-            <a:ext cx="2112264" cy="256032"/>
+            <a:off x="3054096" y="5157216"/>
+            <a:ext cx="2075688" cy="237744"/>
           </a:xfrm>
           <a:prstGeom prst="rect">
             <a:avLst/>
@@ -26345,8 +27101,8 @@
         </p:nvSpPr>
         <p:spPr>
           <a:xfrm>
-            <a:off x="6601968" y="5166360"/>
-            <a:ext cx="2112264" cy="256032"/>
+            <a:off x="6620256" y="5157216"/>
+            <a:ext cx="2075688" cy="237744"/>
           </a:xfrm>
           <a:prstGeom prst="rect">
             <a:avLst/>

</xml_diff>